<commit_message>
Clarify Hard120 definitions and simplify slide 05
</commit_message>
<xml_diff>
--- a/presentations/slide05_hard120_analysis_cn.pptx
+++ b/presentations/slide05_hard120_analysis_cn.pptx
@@ -507,7 +507,7 @@
           </a:p>
           <a:p>
             <a:r>
-              <a:t>Hard定义为WP bearing error&gt;=45deg，n=120/1000；93.333%为turn_strict；18.333%满足goal_err&lt;15且wp&gt;=45。</a:t>
+              <a:t>Hard定义为WP bearing error&gt;=45deg，n=120/1000；93.333%为turn_strict。</a:t>
             </a:r>
           </a:p>
           <a:p>
@@ -532,7 +532,7 @@
           </a:p>
           <a:p>
             <a:r>
-              <a:t>κ是方向分布集中度，较低表明分散程度更高；不采用旧文字结论中“κ更低意味着错还很自信”的错误解释。组间差异只提供历史感知模型的动机，不构成因果证明。</a:t>
+              <a:t>严格转弯标签来自eval_frame_sets.py的turning_mask，对GT横向位移或绝对yaw变化采用OR判定。κ由GoalDirectionHead第三维经softplus+min_kappa得到，标准κ融合直接将该κ用于WP加权；缩放或抑制后得到有效权重，不能称为另一路独立标量。κ是方向分布集中度，较低表明分散程度更高；不采用旧文字结论中“κ更低意味着错还很自信”的错误解释。组间差异只提供历史感知模型的动机，不构成因果证明。</a:t>
             </a:r>
           </a:p>
           <a:p/>
@@ -3764,7 +3764,7 @@
         <p:spPr>
           <a:xfrm>
             <a:off x="685800" y="2249424"/>
-            <a:ext cx="3456432" cy="832104"/>
+            <a:ext cx="5303520" cy="832104"/>
           </a:xfrm>
           <a:prstGeom prst="roundRect">
             <a:avLst>
@@ -3850,7 +3850,7 @@
         <p:spPr>
           <a:xfrm>
             <a:off x="2359152" y="2404872"/>
-            <a:ext cx="1700784" cy="274320"/>
+            <a:ext cx="3502152" cy="274320"/>
           </a:xfrm>
           <a:prstGeom prst="rect">
             <a:avLst/>
@@ -3876,7 +3876,7 @@
               </a:defRPr>
             </a:pPr>
             <a:r>
-              <a:t>困难样本</a:t>
+              <a:t>WP 方向误差 ≥45° 的困难样本</a:t>
             </a:r>
           </a:p>
         </p:txBody>
@@ -3890,7 +3890,7 @@
         <p:spPr>
           <a:xfrm>
             <a:off x="832104" y="2825496"/>
-            <a:ext cx="3200400" cy="201168"/>
+            <a:ext cx="5029200" cy="201168"/>
           </a:xfrm>
           <a:prstGeom prst="rect">
             <a:avLst/>
@@ -3916,7 +3916,7 @@
               </a:defRPr>
             </a:pPr>
             <a:r>
-              <a:t>占锁定远目标帧的 12%</a:t>
+              <a:t>预测 WP 与真实终点方向的夹角；占 locked 1000 帧的 12%</a:t>
             </a:r>
           </a:p>
         </p:txBody>
@@ -3929,8 +3929,8 @@
         </p:nvSpPr>
         <p:spPr>
           <a:xfrm>
-            <a:off x="4370832" y="2249424"/>
-            <a:ext cx="3456432" cy="832104"/>
+            <a:off x="6208776" y="2249424"/>
+            <a:ext cx="5303520" cy="832104"/>
           </a:xfrm>
           <a:prstGeom prst="roundRect">
             <a:avLst>
@@ -3975,7 +3975,7 @@
         </p:nvSpPr>
         <p:spPr>
           <a:xfrm>
-            <a:off x="4517136" y="2340864"/>
+            <a:off x="6355080" y="2340864"/>
             <a:ext cx="1600200" cy="384048"/>
           </a:xfrm>
           <a:prstGeom prst="rect">
@@ -4015,8 +4015,8 @@
         </p:nvSpPr>
         <p:spPr>
           <a:xfrm>
-            <a:off x="6044184" y="2404872"/>
-            <a:ext cx="1700784" cy="274320"/>
+            <a:off x="7882128" y="2404872"/>
+            <a:ext cx="3502152" cy="274320"/>
           </a:xfrm>
           <a:prstGeom prst="rect">
             <a:avLst/>
@@ -4042,7 +4042,7 @@
               </a:defRPr>
             </a:pPr>
             <a:r>
-              <a:t>属于严格转弯</a:t>
+              <a:t>困难样本属于严格转弯</a:t>
             </a:r>
           </a:p>
         </p:txBody>
@@ -4055,8 +4055,8 @@
         </p:nvSpPr>
         <p:spPr>
           <a:xfrm>
-            <a:off x="4517136" y="2825496"/>
-            <a:ext cx="3200400" cy="201168"/>
+            <a:off x="6355080" y="2825496"/>
+            <a:ext cx="5029200" cy="201168"/>
           </a:xfrm>
           <a:prstGeom prst="rect">
             <a:avLst/>
@@ -4082,29 +4082,67 @@
               </a:defRPr>
             </a:pPr>
             <a:r>
-              <a:t>未来短时路径的转弯难例为主</a:t>
-            </a:r>
-          </a:p>
-        </p:txBody>
-      </p:sp>
-      <p:sp>
-        <p:nvSpPr>
-          <p:cNvPr id="15" name="Rounded Rectangle 14"/>
+              <a:t>GT 判定：|横向位移| ≥0.30 m 或 |航向变化| ≥45°</a:t>
+            </a:r>
+          </a:p>
+        </p:txBody>
+      </p:sp>
+      <p:sp>
+        <p:nvSpPr>
+          <p:cNvPr id="15" name="TextBox 14"/>
+          <p:cNvSpPr txBox="1"/>
+          <p:nvPr/>
+        </p:nvSpPr>
+        <p:spPr>
+          <a:xfrm>
+            <a:off x="685800" y="3291840"/>
+            <a:ext cx="6400800" cy="256032"/>
+          </a:xfrm>
+          <a:prstGeom prst="rect">
+            <a:avLst/>
+          </a:prstGeom>
+          <a:noFill/>
+          <a:effectLst/>
+        </p:spPr>
+        <p:txBody>
+          <a:bodyPr wrap="none" lIns="0" rIns="0" tIns="0" bIns="0">
+            <a:spAutoFit/>
+          </a:bodyPr>
+          <a:lstStyle/>
+          <a:p>
+            <a:pPr>
+              <a:spcAft>
+                <a:spcPts val="700"/>
+              </a:spcAft>
+              <a:defRPr sz="1500" b="1">
+                <a:solidFill>
+                  <a:srgbClr val="142B46"/>
+                </a:solidFill>
+                <a:latin typeface="Noto Sans CJK SC"/>
+              </a:defRPr>
+            </a:pPr>
+            <a:r>
+              <a:t>特征对比：困难组 vs 匹配对照（中位数）</a:t>
+            </a:r>
+          </a:p>
+        </p:txBody>
+      </p:sp>
+      <p:sp>
+        <p:nvSpPr>
+          <p:cNvPr id="16" name="Rectangle 15"/>
           <p:cNvSpPr/>
           <p:nvPr/>
         </p:nvSpPr>
         <p:spPr>
           <a:xfrm>
-            <a:off x="8055864" y="2249424"/>
-            <a:ext cx="3456432" cy="832104"/>
-          </a:xfrm>
-          <a:prstGeom prst="roundRect">
-            <a:avLst>
-              <a:gd name="adj" fmla="val 12000"/>
-            </a:avLst>
+            <a:off x="8330183" y="3328416"/>
+            <a:ext cx="155448" cy="118872"/>
+          </a:xfrm>
+          <a:prstGeom prst="rect">
+            <a:avLst/>
           </a:prstGeom>
           <a:solidFill>
-            <a:srgbClr val="ECF1F7"/>
+            <a:srgbClr val="148D91"/>
           </a:solidFill>
           <a:ln>
             <a:noFill/>
@@ -4135,94 +4173,14 @@
       </p:sp>
       <p:sp>
         <p:nvSpPr>
-          <p:cNvPr id="16" name="TextBox 15"/>
-          <p:cNvSpPr txBox="1"/>
-          <p:nvPr/>
-        </p:nvSpPr>
-        <p:spPr>
-          <a:xfrm>
-            <a:off x="8202168" y="2340864"/>
-            <a:ext cx="1600200" cy="384048"/>
-          </a:xfrm>
-          <a:prstGeom prst="rect">
-            <a:avLst/>
-          </a:prstGeom>
-          <a:noFill/>
-          <a:effectLst/>
-        </p:spPr>
-        <p:txBody>
-          <a:bodyPr wrap="none" lIns="0" rIns="0" tIns="0" bIns="0">
-            <a:spAutoFit/>
-          </a:bodyPr>
-          <a:lstStyle/>
-          <a:p>
-            <a:pPr>
-              <a:spcAft>
-                <a:spcPts val="700"/>
-              </a:spcAft>
-              <a:defRPr sz="2400" b="1">
-                <a:solidFill>
-                  <a:srgbClr val="148D91"/>
-                </a:solidFill>
-                <a:latin typeface="Noto Sans CJK SC"/>
-              </a:defRPr>
-            </a:pPr>
-            <a:r>
-              <a:t>18.3%</a:t>
-            </a:r>
-          </a:p>
-        </p:txBody>
-      </p:sp>
-      <p:sp>
-        <p:nvSpPr>
           <p:cNvPr id="17" name="TextBox 16"/>
           <p:cNvSpPr txBox="1"/>
           <p:nvPr/>
         </p:nvSpPr>
         <p:spPr>
           <a:xfrm>
-            <a:off x="9729216" y="2404872"/>
-            <a:ext cx="1700784" cy="274320"/>
-          </a:xfrm>
-          <a:prstGeom prst="rect">
-            <a:avLst/>
-          </a:prstGeom>
-          <a:noFill/>
-          <a:effectLst/>
-        </p:spPr>
-        <p:txBody>
-          <a:bodyPr wrap="none" lIns="0" rIns="0" tIns="0" bIns="0">
-            <a:spAutoFit/>
-          </a:bodyPr>
-          <a:lstStyle/>
-          <a:p>
-            <a:pPr>
-              <a:spcAft>
-                <a:spcPts val="700"/>
-              </a:spcAft>
-              <a:defRPr sz="1200" b="1">
-                <a:solidFill>
-                  <a:srgbClr val="142B46"/>
-                </a:solidFill>
-                <a:latin typeface="Noto Sans CJK SC"/>
-              </a:defRPr>
-            </a:pPr>
-            <a:r>
-              <a:t>Goal 仍较准确</a:t>
-            </a:r>
-          </a:p>
-        </p:txBody>
-      </p:sp>
-      <p:sp>
-        <p:nvSpPr>
-          <p:cNvPr id="18" name="TextBox 17"/>
-          <p:cNvSpPr txBox="1"/>
-          <p:nvPr/>
-        </p:nvSpPr>
-        <p:spPr>
-          <a:xfrm>
-            <a:off x="8202168" y="2825496"/>
-            <a:ext cx="3200400" cy="201168"/>
+            <a:off x="8577072" y="3264408"/>
+            <a:ext cx="1188720" cy="228600"/>
           </a:xfrm>
           <a:prstGeom prst="rect">
             <a:avLst/>
@@ -4248,67 +4206,27 @@
               </a:defRPr>
             </a:pPr>
             <a:r>
-              <a:t>仅这部分难例的 Goal 误差 &lt;15°</a:t>
-            </a:r>
-          </a:p>
-        </p:txBody>
-      </p:sp>
-      <p:sp>
-        <p:nvSpPr>
-          <p:cNvPr id="19" name="TextBox 18"/>
-          <p:cNvSpPr txBox="1"/>
-          <p:nvPr/>
-        </p:nvSpPr>
-        <p:spPr>
-          <a:xfrm>
-            <a:off x="685800" y="3291840"/>
-            <a:ext cx="6400800" cy="256032"/>
-          </a:xfrm>
-          <a:prstGeom prst="rect">
-            <a:avLst/>
-          </a:prstGeom>
-          <a:noFill/>
-          <a:effectLst/>
-        </p:spPr>
-        <p:txBody>
-          <a:bodyPr wrap="none" lIns="0" rIns="0" tIns="0" bIns="0">
-            <a:spAutoFit/>
-          </a:bodyPr>
-          <a:lstStyle/>
-          <a:p>
-            <a:pPr>
-              <a:spcAft>
-                <a:spcPts val="700"/>
-              </a:spcAft>
-              <a:defRPr sz="1500" b="1">
-                <a:solidFill>
-                  <a:srgbClr val="142B46"/>
-                </a:solidFill>
-                <a:latin typeface="Noto Sans CJK SC"/>
-              </a:defRPr>
-            </a:pPr>
-            <a:r>
-              <a:t>特征对比：困难组 vs 匹配对照（中位数）</a:t>
-            </a:r>
-          </a:p>
-        </p:txBody>
-      </p:sp>
-      <p:sp>
-        <p:nvSpPr>
-          <p:cNvPr id="20" name="Rectangle 19"/>
+              <a:t>困难组</a:t>
+            </a:r>
+          </a:p>
+        </p:txBody>
+      </p:sp>
+      <p:sp>
+        <p:nvSpPr>
+          <p:cNvPr id="18" name="Rectangle 17"/>
           <p:cNvSpPr/>
           <p:nvPr/>
         </p:nvSpPr>
         <p:spPr>
           <a:xfrm>
-            <a:off x="8330183" y="3328416"/>
+            <a:off x="9857232" y="3328416"/>
             <a:ext cx="155448" cy="118872"/>
           </a:xfrm>
           <a:prstGeom prst="rect">
             <a:avLst/>
           </a:prstGeom>
           <a:solidFill>
-            <a:srgbClr val="148D91"/>
+            <a:srgbClr val="9CB5D8"/>
           </a:solidFill>
           <a:ln>
             <a:noFill/>
@@ -4339,14 +4257,14 @@
       </p:sp>
       <p:sp>
         <p:nvSpPr>
-          <p:cNvPr id="21" name="TextBox 20"/>
+          <p:cNvPr id="19" name="TextBox 18"/>
           <p:cNvSpPr txBox="1"/>
           <p:nvPr/>
         </p:nvSpPr>
         <p:spPr>
           <a:xfrm>
-            <a:off x="8577072" y="3264408"/>
-            <a:ext cx="1188720" cy="228600"/>
+            <a:off x="10104120" y="3264408"/>
+            <a:ext cx="1371600" cy="228600"/>
           </a:xfrm>
           <a:prstGeom prst="rect">
             <a:avLst/>
@@ -4372,27 +4290,29 @@
               </a:defRPr>
             </a:pPr>
             <a:r>
-              <a:t>困难组</a:t>
-            </a:r>
-          </a:p>
-        </p:txBody>
-      </p:sp>
-      <p:sp>
-        <p:nvSpPr>
-          <p:cNvPr id="22" name="Rectangle 21"/>
+              <a:t>匹配对照</a:t>
+            </a:r>
+          </a:p>
+        </p:txBody>
+      </p:sp>
+      <p:sp>
+        <p:nvSpPr>
+          <p:cNvPr id="20" name="Rounded Rectangle 19"/>
           <p:cNvSpPr/>
           <p:nvPr/>
         </p:nvSpPr>
         <p:spPr>
           <a:xfrm>
-            <a:off x="9857232" y="3328416"/>
-            <a:ext cx="155448" cy="118872"/>
-          </a:xfrm>
-          <a:prstGeom prst="rect">
-            <a:avLst/>
+            <a:off x="685800" y="3675887"/>
+            <a:ext cx="2542032" cy="1728216"/>
+          </a:xfrm>
+          <a:prstGeom prst="roundRect">
+            <a:avLst>
+              <a:gd name="adj" fmla="val 12000"/>
+            </a:avLst>
           </a:prstGeom>
           <a:solidFill>
-            <a:srgbClr val="9CB5D8"/>
+            <a:srgbClr val="F0F4F8"/>
           </a:solidFill>
           <a:ln>
             <a:noFill/>
@@ -4423,14 +4343,54 @@
       </p:sp>
       <p:sp>
         <p:nvSpPr>
-          <p:cNvPr id="23" name="TextBox 22"/>
+          <p:cNvPr id="21" name="TextBox 20"/>
           <p:cNvSpPr txBox="1"/>
           <p:nvPr/>
         </p:nvSpPr>
         <p:spPr>
           <a:xfrm>
-            <a:off x="10104120" y="3264408"/>
-            <a:ext cx="1371600" cy="228600"/>
+            <a:off x="822960" y="3831336"/>
+            <a:ext cx="2286000" cy="283464"/>
+          </a:xfrm>
+          <a:prstGeom prst="rect">
+            <a:avLst/>
+          </a:prstGeom>
+          <a:noFill/>
+          <a:effectLst/>
+        </p:spPr>
+        <p:txBody>
+          <a:bodyPr wrap="none" lIns="0" rIns="0" tIns="0" bIns="0">
+            <a:spAutoFit/>
+          </a:bodyPr>
+          <a:lstStyle/>
+          <a:p>
+            <a:pPr>
+              <a:spcAft>
+                <a:spcPts val="700"/>
+              </a:spcAft>
+              <a:defRPr sz="1300" b="1">
+                <a:solidFill>
+                  <a:srgbClr val="142B46"/>
+                </a:solidFill>
+                <a:latin typeface="Noto Sans CJK SC"/>
+              </a:defRPr>
+            </a:pPr>
+            <a:r>
+              <a:t>未来 8 步累计转角</a:t>
+            </a:r>
+          </a:p>
+        </p:txBody>
+      </p:sp>
+      <p:sp>
+        <p:nvSpPr>
+          <p:cNvPr id="22" name="TextBox 21"/>
+          <p:cNvSpPr txBox="1"/>
+          <p:nvPr/>
+        </p:nvSpPr>
+        <p:spPr>
+          <a:xfrm>
+            <a:off x="822960" y="4187952"/>
+            <a:ext cx="2286000" cy="237744"/>
           </a:xfrm>
           <a:prstGeom prst="rect">
             <a:avLst/>
@@ -4456,21 +4416,21 @@
               </a:defRPr>
             </a:pPr>
             <a:r>
-              <a:t>匹配对照</a:t>
-            </a:r>
-          </a:p>
-        </p:txBody>
-      </p:sp>
-      <p:sp>
-        <p:nvSpPr>
-          <p:cNvPr id="24" name="Rounded Rectangle 23"/>
+              <a:t>路径弯曲程度</a:t>
+            </a:r>
+          </a:p>
+        </p:txBody>
+      </p:sp>
+      <p:sp>
+        <p:nvSpPr>
+          <p:cNvPr id="23" name="Rounded Rectangle 22"/>
           <p:cNvSpPr/>
           <p:nvPr/>
         </p:nvSpPr>
         <p:spPr>
           <a:xfrm>
-            <a:off x="685800" y="3675887"/>
-            <a:ext cx="2542032" cy="1728216"/>
+            <a:off x="822960" y="4668012"/>
+            <a:ext cx="1320800" cy="146304"/>
           </a:xfrm>
           <a:prstGeom prst="roundRect">
             <a:avLst>
@@ -4478,7 +4438,7 @@
             </a:avLst>
           </a:prstGeom>
           <a:solidFill>
-            <a:srgbClr val="F0F4F8"/>
+            <a:srgbClr val="148D91"/>
           </a:solidFill>
           <a:ln>
             <a:noFill/>
@@ -4509,14 +4469,14 @@
       </p:sp>
       <p:sp>
         <p:nvSpPr>
-          <p:cNvPr id="25" name="TextBox 24"/>
+          <p:cNvPr id="24" name="TextBox 23"/>
           <p:cNvSpPr txBox="1"/>
           <p:nvPr/>
         </p:nvSpPr>
         <p:spPr>
           <a:xfrm>
-            <a:off x="822960" y="3831336"/>
-            <a:ext cx="2286000" cy="283464"/>
+            <a:off x="2340864" y="4576572"/>
+            <a:ext cx="813816" cy="292608"/>
           </a:xfrm>
           <a:prstGeom prst="rect">
             <a:avLst/>
@@ -4534,69 +4494,29 @@
               <a:spcAft>
                 <a:spcPts val="700"/>
               </a:spcAft>
-              <a:defRPr sz="1300" b="1">
+              <a:defRPr sz="1400" b="1">
                 <a:solidFill>
-                  <a:srgbClr val="142B46"/>
+                  <a:srgbClr val="148D91"/>
                 </a:solidFill>
                 <a:latin typeface="Noto Sans CJK SC"/>
               </a:defRPr>
             </a:pPr>
             <a:r>
-              <a:t>未来 8 步累计转角</a:t>
-            </a:r>
-          </a:p>
-        </p:txBody>
-      </p:sp>
-      <p:sp>
-        <p:nvSpPr>
-          <p:cNvPr id="26" name="TextBox 25"/>
-          <p:cNvSpPr txBox="1"/>
-          <p:nvPr/>
-        </p:nvSpPr>
-        <p:spPr>
-          <a:xfrm>
-            <a:off x="822960" y="4187952"/>
-            <a:ext cx="2286000" cy="237744"/>
-          </a:xfrm>
-          <a:prstGeom prst="rect">
-            <a:avLst/>
-          </a:prstGeom>
-          <a:noFill/>
-          <a:effectLst/>
-        </p:spPr>
-        <p:txBody>
-          <a:bodyPr wrap="none" lIns="0" rIns="0" tIns="0" bIns="0">
-            <a:spAutoFit/>
-          </a:bodyPr>
-          <a:lstStyle/>
-          <a:p>
-            <a:pPr>
-              <a:spcAft>
-                <a:spcPts val="700"/>
-              </a:spcAft>
-              <a:defRPr sz="1000" b="0">
-                <a:solidFill>
-                  <a:srgbClr val="62748A"/>
-                </a:solidFill>
-                <a:latin typeface="Noto Sans CJK SC"/>
-              </a:defRPr>
-            </a:pPr>
-            <a:r>
-              <a:t>路径弯曲程度</a:t>
-            </a:r>
-          </a:p>
-        </p:txBody>
-      </p:sp>
-      <p:sp>
-        <p:nvSpPr>
-          <p:cNvPr id="27" name="Rounded Rectangle 26"/>
+              <a:t>108.5°</a:t>
+            </a:r>
+          </a:p>
+        </p:txBody>
+      </p:sp>
+      <p:sp>
+        <p:nvSpPr>
+          <p:cNvPr id="25" name="Rounded Rectangle 24"/>
           <p:cNvSpPr/>
           <p:nvPr/>
         </p:nvSpPr>
         <p:spPr>
           <a:xfrm>
-            <a:off x="822960" y="4668012"/>
-            <a:ext cx="1320800" cy="146304"/>
+            <a:off x="822960" y="5052060"/>
+            <a:ext cx="845321" cy="146304"/>
           </a:xfrm>
           <a:prstGeom prst="roundRect">
             <a:avLst>
@@ -4604,7 +4524,7 @@
             </a:avLst>
           </a:prstGeom>
           <a:solidFill>
-            <a:srgbClr val="148D91"/>
+            <a:srgbClr val="9CB5D8"/>
           </a:solidFill>
           <a:ln>
             <a:noFill/>
@@ -4635,13 +4555,13 @@
       </p:sp>
       <p:sp>
         <p:nvSpPr>
-          <p:cNvPr id="28" name="TextBox 27"/>
+          <p:cNvPr id="26" name="TextBox 25"/>
           <p:cNvSpPr txBox="1"/>
           <p:nvPr/>
         </p:nvSpPr>
         <p:spPr>
           <a:xfrm>
-            <a:off x="2340864" y="4576572"/>
+            <a:off x="2340864" y="4960620"/>
             <a:ext cx="813816" cy="292608"/>
           </a:xfrm>
           <a:prstGeom prst="rect">
@@ -4662,27 +4582,27 @@
               </a:spcAft>
               <a:defRPr sz="1400" b="1">
                 <a:solidFill>
-                  <a:srgbClr val="148D91"/>
+                  <a:srgbClr val="62748A"/>
                 </a:solidFill>
                 <a:latin typeface="Noto Sans CJK SC"/>
               </a:defRPr>
             </a:pPr>
             <a:r>
-              <a:t>108.5°</a:t>
-            </a:r>
-          </a:p>
-        </p:txBody>
-      </p:sp>
-      <p:sp>
-        <p:nvSpPr>
-          <p:cNvPr id="29" name="Rounded Rectangle 28"/>
+              <a:t>69.4°</a:t>
+            </a:r>
+          </a:p>
+        </p:txBody>
+      </p:sp>
+      <p:sp>
+        <p:nvSpPr>
+          <p:cNvPr id="27" name="Rounded Rectangle 26"/>
           <p:cNvSpPr/>
           <p:nvPr/>
         </p:nvSpPr>
         <p:spPr>
           <a:xfrm>
-            <a:off x="822960" y="5052060"/>
-            <a:ext cx="845321" cy="146304"/>
+            <a:off x="3447288" y="3675887"/>
+            <a:ext cx="2542032" cy="1728216"/>
           </a:xfrm>
           <a:prstGeom prst="roundRect">
             <a:avLst>
@@ -4690,7 +4610,7 @@
             </a:avLst>
           </a:prstGeom>
           <a:solidFill>
-            <a:srgbClr val="9CB5D8"/>
+            <a:srgbClr val="F0F4F8"/>
           </a:solidFill>
           <a:ln>
             <a:noFill/>
@@ -4721,14 +4641,14 @@
       </p:sp>
       <p:sp>
         <p:nvSpPr>
-          <p:cNvPr id="30" name="TextBox 29"/>
+          <p:cNvPr id="28" name="TextBox 27"/>
           <p:cNvSpPr txBox="1"/>
           <p:nvPr/>
         </p:nvSpPr>
         <p:spPr>
           <a:xfrm>
-            <a:off x="2340864" y="4960620"/>
-            <a:ext cx="813816" cy="292608"/>
+            <a:off x="3584448" y="3831336"/>
+            <a:ext cx="2286000" cy="283464"/>
           </a:xfrm>
           <a:prstGeom prst="rect">
             <a:avLst/>
@@ -4746,7 +4666,47 @@
               <a:spcAft>
                 <a:spcPts val="700"/>
               </a:spcAft>
-              <a:defRPr sz="1400" b="1">
+              <a:defRPr sz="1300" b="1">
+                <a:solidFill>
+                  <a:srgbClr val="142B46"/>
+                </a:solidFill>
+                <a:latin typeface="Noto Sans CJK SC"/>
+              </a:defRPr>
+            </a:pPr>
+            <a:r>
+              <a:t>历史平均步间转角</a:t>
+            </a:r>
+          </a:p>
+        </p:txBody>
+      </p:sp>
+      <p:sp>
+        <p:nvSpPr>
+          <p:cNvPr id="29" name="TextBox 28"/>
+          <p:cNvSpPr txBox="1"/>
+          <p:nvPr/>
+        </p:nvSpPr>
+        <p:spPr>
+          <a:xfrm>
+            <a:off x="3584448" y="4187952"/>
+            <a:ext cx="2286000" cy="237744"/>
+          </a:xfrm>
+          <a:prstGeom prst="rect">
+            <a:avLst/>
+          </a:prstGeom>
+          <a:noFill/>
+          <a:effectLst/>
+        </p:spPr>
+        <p:txBody>
+          <a:bodyPr wrap="none" lIns="0" rIns="0" tIns="0" bIns="0">
+            <a:spAutoFit/>
+          </a:bodyPr>
+          <a:lstStyle/>
+          <a:p>
+            <a:pPr>
+              <a:spcAft>
+                <a:spcPts val="700"/>
+              </a:spcAft>
+              <a:defRPr sz="1000" b="0">
                 <a:solidFill>
                   <a:srgbClr val="62748A"/>
                 </a:solidFill>
@@ -4754,21 +4714,21 @@
               </a:defRPr>
             </a:pPr>
             <a:r>
-              <a:t>69.4°</a:t>
-            </a:r>
-          </a:p>
-        </p:txBody>
-      </p:sp>
-      <p:sp>
-        <p:nvSpPr>
-          <p:cNvPr id="31" name="Rounded Rectangle 30"/>
+              <a:t>过去 3 步的 |Δyaw| 均值</a:t>
+            </a:r>
+          </a:p>
+        </p:txBody>
+      </p:sp>
+      <p:sp>
+        <p:nvSpPr>
+          <p:cNvPr id="30" name="Rounded Rectangle 29"/>
           <p:cNvSpPr/>
           <p:nvPr/>
         </p:nvSpPr>
         <p:spPr>
           <a:xfrm>
-            <a:off x="3447288" y="3675887"/>
-            <a:ext cx="2542032" cy="1728216"/>
+            <a:off x="3584448" y="4668012"/>
+            <a:ext cx="1320800" cy="146304"/>
           </a:xfrm>
           <a:prstGeom prst="roundRect">
             <a:avLst>
@@ -4776,7 +4736,7 @@
             </a:avLst>
           </a:prstGeom>
           <a:solidFill>
-            <a:srgbClr val="F0F4F8"/>
+            <a:srgbClr val="148D91"/>
           </a:solidFill>
           <a:ln>
             <a:noFill/>
@@ -4807,14 +4767,14 @@
       </p:sp>
       <p:sp>
         <p:nvSpPr>
-          <p:cNvPr id="32" name="TextBox 31"/>
+          <p:cNvPr id="31" name="TextBox 30"/>
           <p:cNvSpPr txBox="1"/>
           <p:nvPr/>
         </p:nvSpPr>
         <p:spPr>
           <a:xfrm>
-            <a:off x="3584448" y="3831336"/>
-            <a:ext cx="2286000" cy="283464"/>
+            <a:off x="5102352" y="4576572"/>
+            <a:ext cx="813816" cy="292608"/>
           </a:xfrm>
           <a:prstGeom prst="rect">
             <a:avLst/>
@@ -4832,69 +4792,29 @@
               <a:spcAft>
                 <a:spcPts val="700"/>
               </a:spcAft>
-              <a:defRPr sz="1300" b="1">
+              <a:defRPr sz="1400" b="1">
                 <a:solidFill>
-                  <a:srgbClr val="142B46"/>
+                  <a:srgbClr val="148D91"/>
                 </a:solidFill>
                 <a:latin typeface="Noto Sans CJK SC"/>
               </a:defRPr>
             </a:pPr>
             <a:r>
-              <a:t>历史平均步间转角</a:t>
-            </a:r>
-          </a:p>
-        </p:txBody>
-      </p:sp>
-      <p:sp>
-        <p:nvSpPr>
-          <p:cNvPr id="33" name="TextBox 32"/>
-          <p:cNvSpPr txBox="1"/>
-          <p:nvPr/>
-        </p:nvSpPr>
-        <p:spPr>
-          <a:xfrm>
-            <a:off x="3584448" y="4187952"/>
-            <a:ext cx="2286000" cy="237744"/>
-          </a:xfrm>
-          <a:prstGeom prst="rect">
-            <a:avLst/>
-          </a:prstGeom>
-          <a:noFill/>
-          <a:effectLst/>
-        </p:spPr>
-        <p:txBody>
-          <a:bodyPr wrap="none" lIns="0" rIns="0" tIns="0" bIns="0">
-            <a:spAutoFit/>
-          </a:bodyPr>
-          <a:lstStyle/>
-          <a:p>
-            <a:pPr>
-              <a:spcAft>
-                <a:spcPts val="700"/>
-              </a:spcAft>
-              <a:defRPr sz="1000" b="0">
-                <a:solidFill>
-                  <a:srgbClr val="62748A"/>
-                </a:solidFill>
-                <a:latin typeface="Noto Sans CJK SC"/>
-              </a:defRPr>
-            </a:pPr>
-            <a:r>
-              <a:t>过去 3 步的 |Δyaw| 均值</a:t>
-            </a:r>
-          </a:p>
-        </p:txBody>
-      </p:sp>
-      <p:sp>
-        <p:nvSpPr>
-          <p:cNvPr id="34" name="Rounded Rectangle 33"/>
+              <a:t>14.1°</a:t>
+            </a:r>
+          </a:p>
+        </p:txBody>
+      </p:sp>
+      <p:sp>
+        <p:nvSpPr>
+          <p:cNvPr id="32" name="Rounded Rectangle 31"/>
           <p:cNvSpPr/>
           <p:nvPr/>
         </p:nvSpPr>
         <p:spPr>
           <a:xfrm>
-            <a:off x="3584448" y="4668012"/>
-            <a:ext cx="1320800" cy="146304"/>
+            <a:off x="3584448" y="5052060"/>
+            <a:ext cx="688395" cy="146304"/>
           </a:xfrm>
           <a:prstGeom prst="roundRect">
             <a:avLst>
@@ -4902,7 +4822,7 @@
             </a:avLst>
           </a:prstGeom>
           <a:solidFill>
-            <a:srgbClr val="148D91"/>
+            <a:srgbClr val="9CB5D8"/>
           </a:solidFill>
           <a:ln>
             <a:noFill/>
@@ -4933,13 +4853,13 @@
       </p:sp>
       <p:sp>
         <p:nvSpPr>
-          <p:cNvPr id="35" name="TextBox 34"/>
+          <p:cNvPr id="33" name="TextBox 32"/>
           <p:cNvSpPr txBox="1"/>
           <p:nvPr/>
         </p:nvSpPr>
         <p:spPr>
           <a:xfrm>
-            <a:off x="5102352" y="4576572"/>
+            <a:off x="5102352" y="4960620"/>
             <a:ext cx="813816" cy="292608"/>
           </a:xfrm>
           <a:prstGeom prst="rect">
@@ -4960,27 +4880,27 @@
               </a:spcAft>
               <a:defRPr sz="1400" b="1">
                 <a:solidFill>
-                  <a:srgbClr val="148D91"/>
+                  <a:srgbClr val="62748A"/>
                 </a:solidFill>
                 <a:latin typeface="Noto Sans CJK SC"/>
               </a:defRPr>
             </a:pPr>
             <a:r>
-              <a:t>14.1°</a:t>
-            </a:r>
-          </a:p>
-        </p:txBody>
-      </p:sp>
-      <p:sp>
-        <p:nvSpPr>
-          <p:cNvPr id="36" name="Rounded Rectangle 35"/>
+              <a:t>7.3°</a:t>
+            </a:r>
+          </a:p>
+        </p:txBody>
+      </p:sp>
+      <p:sp>
+        <p:nvSpPr>
+          <p:cNvPr id="34" name="Rounded Rectangle 33"/>
           <p:cNvSpPr/>
           <p:nvPr/>
         </p:nvSpPr>
         <p:spPr>
           <a:xfrm>
-            <a:off x="3584448" y="5052060"/>
-            <a:ext cx="688395" cy="146304"/>
+            <a:off x="6208776" y="3675887"/>
+            <a:ext cx="2542032" cy="1728216"/>
           </a:xfrm>
           <a:prstGeom prst="roundRect">
             <a:avLst>
@@ -4988,7 +4908,7 @@
             </a:avLst>
           </a:prstGeom>
           <a:solidFill>
-            <a:srgbClr val="9CB5D8"/>
+            <a:srgbClr val="F0F4F8"/>
           </a:solidFill>
           <a:ln>
             <a:noFill/>
@@ -5019,14 +4939,14 @@
       </p:sp>
       <p:sp>
         <p:nvSpPr>
-          <p:cNvPr id="37" name="TextBox 36"/>
+          <p:cNvPr id="35" name="TextBox 34"/>
           <p:cNvSpPr txBox="1"/>
           <p:nvPr/>
         </p:nvSpPr>
         <p:spPr>
           <a:xfrm>
-            <a:off x="5102352" y="4960620"/>
-            <a:ext cx="813816" cy="292608"/>
+            <a:off x="6345936" y="3831336"/>
+            <a:ext cx="2286000" cy="283464"/>
           </a:xfrm>
           <a:prstGeom prst="rect">
             <a:avLst/>
@@ -5044,7 +4964,47 @@
               <a:spcAft>
                 <a:spcPts val="700"/>
               </a:spcAft>
-              <a:defRPr sz="1400" b="1">
+              <a:defRPr sz="1300" b="1">
+                <a:solidFill>
+                  <a:srgbClr val="142B46"/>
+                </a:solidFill>
+                <a:latin typeface="Noto Sans CJK SC"/>
+              </a:defRPr>
+            </a:pPr>
+            <a:r>
+              <a:t>全局目标方位误差</a:t>
+            </a:r>
+          </a:p>
+        </p:txBody>
+      </p:sp>
+      <p:sp>
+        <p:nvSpPr>
+          <p:cNvPr id="36" name="TextBox 35"/>
+          <p:cNvSpPr txBox="1"/>
+          <p:nvPr/>
+        </p:nvSpPr>
+        <p:spPr>
+          <a:xfrm>
+            <a:off x="6345936" y="4187952"/>
+            <a:ext cx="2286000" cy="237744"/>
+          </a:xfrm>
+          <a:prstGeom prst="rect">
+            <a:avLst/>
+          </a:prstGeom>
+          <a:noFill/>
+          <a:effectLst/>
+        </p:spPr>
+        <p:txBody>
+          <a:bodyPr wrap="none" lIns="0" rIns="0" tIns="0" bIns="0">
+            <a:spAutoFit/>
+          </a:bodyPr>
+          <a:lstStyle/>
+          <a:p>
+            <a:pPr>
+              <a:spcAft>
+                <a:spcPts val="700"/>
+              </a:spcAft>
+              <a:defRPr sz="1000" b="0">
                 <a:solidFill>
                   <a:srgbClr val="62748A"/>
                 </a:solidFill>
@@ -5052,21 +5012,21 @@
               </a:defRPr>
             </a:pPr>
             <a:r>
-              <a:t>7.3°</a:t>
-            </a:r>
-          </a:p>
-        </p:txBody>
-      </p:sp>
-      <p:sp>
-        <p:nvSpPr>
-          <p:cNvPr id="38" name="Rounded Rectangle 37"/>
+              <a:t>Goal 方向也常同时出错</a:t>
+            </a:r>
+          </a:p>
+        </p:txBody>
+      </p:sp>
+      <p:sp>
+        <p:nvSpPr>
+          <p:cNvPr id="37" name="Rounded Rectangle 36"/>
           <p:cNvSpPr/>
           <p:nvPr/>
         </p:nvSpPr>
         <p:spPr>
           <a:xfrm>
-            <a:off x="6208776" y="3675887"/>
-            <a:ext cx="2542032" cy="1728216"/>
+            <a:off x="6345936" y="4668012"/>
+            <a:ext cx="1320799" cy="146304"/>
           </a:xfrm>
           <a:prstGeom prst="roundRect">
             <a:avLst>
@@ -5074,7 +5034,7 @@
             </a:avLst>
           </a:prstGeom>
           <a:solidFill>
-            <a:srgbClr val="F0F4F8"/>
+            <a:srgbClr val="148D91"/>
           </a:solidFill>
           <a:ln>
             <a:noFill/>
@@ -5105,14 +5065,14 @@
       </p:sp>
       <p:sp>
         <p:nvSpPr>
-          <p:cNvPr id="39" name="TextBox 38"/>
+          <p:cNvPr id="38" name="TextBox 37"/>
           <p:cNvSpPr txBox="1"/>
           <p:nvPr/>
         </p:nvSpPr>
         <p:spPr>
           <a:xfrm>
-            <a:off x="6345936" y="3831336"/>
-            <a:ext cx="2286000" cy="283464"/>
+            <a:off x="7863840" y="4576572"/>
+            <a:ext cx="813816" cy="292608"/>
           </a:xfrm>
           <a:prstGeom prst="rect">
             <a:avLst/>
@@ -5130,69 +5090,29 @@
               <a:spcAft>
                 <a:spcPts val="700"/>
               </a:spcAft>
-              <a:defRPr sz="1300" b="1">
+              <a:defRPr sz="1400" b="1">
                 <a:solidFill>
-                  <a:srgbClr val="142B46"/>
+                  <a:srgbClr val="148D91"/>
                 </a:solidFill>
                 <a:latin typeface="Noto Sans CJK SC"/>
               </a:defRPr>
             </a:pPr>
             <a:r>
-              <a:t>全局目标方位误差</a:t>
-            </a:r>
-          </a:p>
-        </p:txBody>
-      </p:sp>
-      <p:sp>
-        <p:nvSpPr>
-          <p:cNvPr id="40" name="TextBox 39"/>
-          <p:cNvSpPr txBox="1"/>
-          <p:nvPr/>
-        </p:nvSpPr>
-        <p:spPr>
-          <a:xfrm>
-            <a:off x="6345936" y="4187952"/>
-            <a:ext cx="2286000" cy="237744"/>
-          </a:xfrm>
-          <a:prstGeom prst="rect">
-            <a:avLst/>
-          </a:prstGeom>
-          <a:noFill/>
-          <a:effectLst/>
-        </p:spPr>
-        <p:txBody>
-          <a:bodyPr wrap="none" lIns="0" rIns="0" tIns="0" bIns="0">
-            <a:spAutoFit/>
-          </a:bodyPr>
-          <a:lstStyle/>
-          <a:p>
-            <a:pPr>
-              <a:spcAft>
-                <a:spcPts val="700"/>
-              </a:spcAft>
-              <a:defRPr sz="1000" b="0">
-                <a:solidFill>
-                  <a:srgbClr val="62748A"/>
-                </a:solidFill>
-                <a:latin typeface="Noto Sans CJK SC"/>
-              </a:defRPr>
-            </a:pPr>
-            <a:r>
-              <a:t>Goal 方向也常同时出错</a:t>
-            </a:r>
-          </a:p>
-        </p:txBody>
-      </p:sp>
-      <p:sp>
-        <p:nvSpPr>
-          <p:cNvPr id="41" name="Rounded Rectangle 40"/>
+              <a:t>50.4°</a:t>
+            </a:r>
+          </a:p>
+        </p:txBody>
+      </p:sp>
+      <p:sp>
+        <p:nvSpPr>
+          <p:cNvPr id="39" name="Rounded Rectangle 38"/>
           <p:cNvSpPr/>
           <p:nvPr/>
         </p:nvSpPr>
         <p:spPr>
           <a:xfrm>
-            <a:off x="6345936" y="4668012"/>
-            <a:ext cx="1320799" cy="146304"/>
+            <a:off x="6345936" y="5052060"/>
+            <a:ext cx="399058" cy="146304"/>
           </a:xfrm>
           <a:prstGeom prst="roundRect">
             <a:avLst>
@@ -5200,7 +5120,7 @@
             </a:avLst>
           </a:prstGeom>
           <a:solidFill>
-            <a:srgbClr val="148D91"/>
+            <a:srgbClr val="9CB5D8"/>
           </a:solidFill>
           <a:ln>
             <a:noFill/>
@@ -5231,13 +5151,13 @@
       </p:sp>
       <p:sp>
         <p:nvSpPr>
-          <p:cNvPr id="42" name="TextBox 41"/>
+          <p:cNvPr id="40" name="TextBox 39"/>
           <p:cNvSpPr txBox="1"/>
           <p:nvPr/>
         </p:nvSpPr>
         <p:spPr>
           <a:xfrm>
-            <a:off x="7863840" y="4576572"/>
+            <a:off x="7863840" y="4960620"/>
             <a:ext cx="813816" cy="292608"/>
           </a:xfrm>
           <a:prstGeom prst="rect">
@@ -5258,27 +5178,27 @@
               </a:spcAft>
               <a:defRPr sz="1400" b="1">
                 <a:solidFill>
-                  <a:srgbClr val="148D91"/>
+                  <a:srgbClr val="62748A"/>
                 </a:solidFill>
                 <a:latin typeface="Noto Sans CJK SC"/>
               </a:defRPr>
             </a:pPr>
             <a:r>
-              <a:t>50.4°</a:t>
-            </a:r>
-          </a:p>
-        </p:txBody>
-      </p:sp>
-      <p:sp>
-        <p:nvSpPr>
-          <p:cNvPr id="43" name="Rounded Rectangle 42"/>
+              <a:t>15.2°</a:t>
+            </a:r>
+          </a:p>
+        </p:txBody>
+      </p:sp>
+      <p:sp>
+        <p:nvSpPr>
+          <p:cNvPr id="41" name="Rounded Rectangle 40"/>
           <p:cNvSpPr/>
           <p:nvPr/>
         </p:nvSpPr>
         <p:spPr>
           <a:xfrm>
-            <a:off x="6345936" y="5052060"/>
-            <a:ext cx="399058" cy="146304"/>
+            <a:off x="8970264" y="3675887"/>
+            <a:ext cx="2542032" cy="1728216"/>
           </a:xfrm>
           <a:prstGeom prst="roundRect">
             <a:avLst>
@@ -5286,7 +5206,7 @@
             </a:avLst>
           </a:prstGeom>
           <a:solidFill>
-            <a:srgbClr val="9CB5D8"/>
+            <a:srgbClr val="F0F4F8"/>
           </a:solidFill>
           <a:ln>
             <a:noFill/>
@@ -5317,14 +5237,14 @@
       </p:sp>
       <p:sp>
         <p:nvSpPr>
-          <p:cNvPr id="44" name="TextBox 43"/>
+          <p:cNvPr id="42" name="TextBox 41"/>
           <p:cNvSpPr txBox="1"/>
           <p:nvPr/>
         </p:nvSpPr>
         <p:spPr>
           <a:xfrm>
-            <a:off x="7863840" y="4960620"/>
-            <a:ext cx="813816" cy="292608"/>
+            <a:off x="9107424" y="3831336"/>
+            <a:ext cx="2286000" cy="283464"/>
           </a:xfrm>
           <a:prstGeom prst="rect">
             <a:avLst/>
@@ -5342,7 +5262,47 @@
               <a:spcAft>
                 <a:spcPts val="700"/>
               </a:spcAft>
-              <a:defRPr sz="1400" b="1">
+              <a:defRPr sz="1300" b="1">
+                <a:solidFill>
+                  <a:srgbClr val="142B46"/>
+                </a:solidFill>
+                <a:latin typeface="Noto Sans CJK SC"/>
+              </a:defRPr>
+            </a:pPr>
+            <a:r>
+              <a:t>WP 方向集中度 κ</a:t>
+            </a:r>
+          </a:p>
+        </p:txBody>
+      </p:sp>
+      <p:sp>
+        <p:nvSpPr>
+          <p:cNvPr id="43" name="TextBox 42"/>
+          <p:cNvSpPr txBox="1"/>
+          <p:nvPr/>
+        </p:nvSpPr>
+        <p:spPr>
+          <a:xfrm>
+            <a:off x="9107424" y="4187952"/>
+            <a:ext cx="2286000" cy="237744"/>
+          </a:xfrm>
+          <a:prstGeom prst="rect">
+            <a:avLst/>
+          </a:prstGeom>
+          <a:noFill/>
+          <a:effectLst/>
+        </p:spPr>
+        <p:txBody>
+          <a:bodyPr wrap="none" lIns="0" rIns="0" tIns="0" bIns="0">
+            <a:spAutoFit/>
+          </a:bodyPr>
+          <a:lstStyle/>
+          <a:p>
+            <a:pPr>
+              <a:spcAft>
+                <a:spcPts val="700"/>
+              </a:spcAft>
+              <a:defRPr sz="1000" b="0">
                 <a:solidFill>
                   <a:srgbClr val="62748A"/>
                 </a:solidFill>
@@ -5350,21 +5310,21 @@
               </a:defRPr>
             </a:pPr>
             <a:r>
-              <a:t>15.2°</a:t>
-            </a:r>
-          </a:p>
-        </p:txBody>
-      </p:sp>
-      <p:sp>
-        <p:nvSpPr>
-          <p:cNvPr id="45" name="Rounded Rectangle 44"/>
+              <a:t>Head 输出，用于融合加权</a:t>
+            </a:r>
+          </a:p>
+        </p:txBody>
+      </p:sp>
+      <p:sp>
+        <p:nvSpPr>
+          <p:cNvPr id="44" name="Rounded Rectangle 43"/>
           <p:cNvSpPr/>
           <p:nvPr/>
         </p:nvSpPr>
         <p:spPr>
           <a:xfrm>
-            <a:off x="8970264" y="3675887"/>
-            <a:ext cx="2542032" cy="1728216"/>
+            <a:off x="9107424" y="4668012"/>
+            <a:ext cx="328627" cy="146304"/>
           </a:xfrm>
           <a:prstGeom prst="roundRect">
             <a:avLst>
@@ -5372,7 +5332,7 @@
             </a:avLst>
           </a:prstGeom>
           <a:solidFill>
-            <a:srgbClr val="F0F4F8"/>
+            <a:srgbClr val="148D91"/>
           </a:solidFill>
           <a:ln>
             <a:noFill/>
@@ -5403,14 +5363,14 @@
       </p:sp>
       <p:sp>
         <p:nvSpPr>
-          <p:cNvPr id="46" name="TextBox 45"/>
+          <p:cNvPr id="45" name="TextBox 44"/>
           <p:cNvSpPr txBox="1"/>
           <p:nvPr/>
         </p:nvSpPr>
         <p:spPr>
           <a:xfrm>
-            <a:off x="9107424" y="3831336"/>
-            <a:ext cx="2286000" cy="283464"/>
+            <a:off x="10625328" y="4576572"/>
+            <a:ext cx="813816" cy="292608"/>
           </a:xfrm>
           <a:prstGeom prst="rect">
             <a:avLst/>
@@ -5428,69 +5388,29 @@
               <a:spcAft>
                 <a:spcPts val="700"/>
               </a:spcAft>
-              <a:defRPr sz="1300" b="1">
+              <a:defRPr sz="1400" b="1">
                 <a:solidFill>
-                  <a:srgbClr val="142B46"/>
+                  <a:srgbClr val="148D91"/>
                 </a:solidFill>
                 <a:latin typeface="Noto Sans CJK SC"/>
               </a:defRPr>
             </a:pPr>
             <a:r>
-              <a:t>WP 方向集中度 κ</a:t>
-            </a:r>
-          </a:p>
-        </p:txBody>
-      </p:sp>
-      <p:sp>
-        <p:nvSpPr>
-          <p:cNvPr id="47" name="TextBox 46"/>
-          <p:cNvSpPr txBox="1"/>
-          <p:nvPr/>
-        </p:nvSpPr>
-        <p:spPr>
-          <a:xfrm>
-            <a:off x="9107424" y="4187952"/>
-            <a:ext cx="2286000" cy="237744"/>
-          </a:xfrm>
-          <a:prstGeom prst="rect">
-            <a:avLst/>
-          </a:prstGeom>
-          <a:noFill/>
-          <a:effectLst/>
-        </p:spPr>
-        <p:txBody>
-          <a:bodyPr wrap="none" lIns="0" rIns="0" tIns="0" bIns="0">
-            <a:spAutoFit/>
-          </a:bodyPr>
-          <a:lstStyle/>
-          <a:p>
-            <a:pPr>
-              <a:spcAft>
-                <a:spcPts val="700"/>
-              </a:spcAft>
-              <a:defRPr sz="1000" b="0">
-                <a:solidFill>
-                  <a:srgbClr val="62748A"/>
-                </a:solidFill>
-                <a:latin typeface="Noto Sans CJK SC"/>
-              </a:defRPr>
-            </a:pPr>
-            <a:r>
-              <a:t>分布集中度，不是误差</a:t>
-            </a:r>
-          </a:p>
-        </p:txBody>
-      </p:sp>
-      <p:sp>
-        <p:nvSpPr>
-          <p:cNvPr id="48" name="Rounded Rectangle 47"/>
+              <a:t>8.9</a:t>
+            </a:r>
+          </a:p>
+        </p:txBody>
+      </p:sp>
+      <p:sp>
+        <p:nvSpPr>
+          <p:cNvPr id="46" name="Rounded Rectangle 45"/>
           <p:cNvSpPr/>
           <p:nvPr/>
         </p:nvSpPr>
         <p:spPr>
           <a:xfrm>
-            <a:off x="9107424" y="4668012"/>
-            <a:ext cx="328627" cy="146304"/>
+            <a:off x="9107424" y="5052060"/>
+            <a:ext cx="1320799" cy="146304"/>
           </a:xfrm>
           <a:prstGeom prst="roundRect">
             <a:avLst>
@@ -5498,7 +5418,7 @@
             </a:avLst>
           </a:prstGeom>
           <a:solidFill>
-            <a:srgbClr val="148D91"/>
+            <a:srgbClr val="9CB5D8"/>
           </a:solidFill>
           <a:ln>
             <a:noFill/>
@@ -5529,13 +5449,13 @@
       </p:sp>
       <p:sp>
         <p:nvSpPr>
-          <p:cNvPr id="49" name="TextBox 48"/>
+          <p:cNvPr id="47" name="TextBox 46"/>
           <p:cNvSpPr txBox="1"/>
           <p:nvPr/>
         </p:nvSpPr>
         <p:spPr>
           <a:xfrm>
-            <a:off x="10625328" y="4576572"/>
+            <a:off x="10625328" y="4960620"/>
             <a:ext cx="813816" cy="292608"/>
           </a:xfrm>
           <a:prstGeom prst="rect">
@@ -5556,27 +5476,67 @@
               </a:spcAft>
               <a:defRPr sz="1400" b="1">
                 <a:solidFill>
-                  <a:srgbClr val="148D91"/>
+                  <a:srgbClr val="62748A"/>
                 </a:solidFill>
                 <a:latin typeface="Noto Sans CJK SC"/>
               </a:defRPr>
             </a:pPr>
             <a:r>
-              <a:t>8.9</a:t>
-            </a:r>
-          </a:p>
-        </p:txBody>
-      </p:sp>
-      <p:sp>
-        <p:nvSpPr>
-          <p:cNvPr id="50" name="Rounded Rectangle 49"/>
+              <a:t>35.8</a:t>
+            </a:r>
+          </a:p>
+        </p:txBody>
+      </p:sp>
+      <p:sp>
+        <p:nvSpPr>
+          <p:cNvPr id="48" name="TextBox 47"/>
+          <p:cNvSpPr txBox="1"/>
+          <p:nvPr/>
+        </p:nvSpPr>
+        <p:spPr>
+          <a:xfrm>
+            <a:off x="685800" y="5541264"/>
+            <a:ext cx="10972800" cy="246888"/>
+          </a:xfrm>
+          <a:prstGeom prst="rect">
+            <a:avLst/>
+          </a:prstGeom>
+          <a:noFill/>
+          <a:effectLst/>
+        </p:spPr>
+        <p:txBody>
+          <a:bodyPr wrap="none" lIns="0" rIns="0" tIns="0" bIns="0">
+            <a:spAutoFit/>
+          </a:bodyPr>
+          <a:lstStyle/>
+          <a:p>
+            <a:pPr>
+              <a:spcAft>
+                <a:spcPts val="700"/>
+              </a:spcAft>
+              <a:defRPr sz="1100" b="0">
+                <a:solidFill>
+                  <a:srgbClr val="62748A"/>
+                </a:solidFill>
+                <a:latin typeface="Noto Sans CJK SC"/>
+              </a:defRPr>
+            </a:pPr>
+            <a:r>
+              <a:t>κ 更低表示预测分布更分散；这些组间差异是相关性证据，不能直接证明因果。</a:t>
+            </a:r>
+          </a:p>
+        </p:txBody>
+      </p:sp>
+      <p:sp>
+        <p:nvSpPr>
+          <p:cNvPr id="49" name="Rounded Rectangle 48"/>
           <p:cNvSpPr/>
           <p:nvPr/>
         </p:nvSpPr>
         <p:spPr>
           <a:xfrm>
-            <a:off x="9107424" y="5052060"/>
-            <a:ext cx="1320799" cy="146304"/>
+            <a:off x="685800" y="5952744"/>
+            <a:ext cx="10826496" cy="448056"/>
           </a:xfrm>
           <a:prstGeom prst="roundRect">
             <a:avLst>
@@ -5584,7 +5544,7 @@
             </a:avLst>
           </a:prstGeom>
           <a:solidFill>
-            <a:srgbClr val="9CB5D8"/>
+            <a:srgbClr val="E8F4F2"/>
           </a:solidFill>
           <a:ln>
             <a:noFill/>
@@ -5615,133 +5575,7 @@
       </p:sp>
       <p:sp>
         <p:nvSpPr>
-          <p:cNvPr id="51" name="TextBox 50"/>
-          <p:cNvSpPr txBox="1"/>
-          <p:nvPr/>
-        </p:nvSpPr>
-        <p:spPr>
-          <a:xfrm>
-            <a:off x="10625328" y="4960620"/>
-            <a:ext cx="813816" cy="292608"/>
-          </a:xfrm>
-          <a:prstGeom prst="rect">
-            <a:avLst/>
-          </a:prstGeom>
-          <a:noFill/>
-          <a:effectLst/>
-        </p:spPr>
-        <p:txBody>
-          <a:bodyPr wrap="none" lIns="0" rIns="0" tIns="0" bIns="0">
-            <a:spAutoFit/>
-          </a:bodyPr>
-          <a:lstStyle/>
-          <a:p>
-            <a:pPr>
-              <a:spcAft>
-                <a:spcPts val="700"/>
-              </a:spcAft>
-              <a:defRPr sz="1400" b="1">
-                <a:solidFill>
-                  <a:srgbClr val="62748A"/>
-                </a:solidFill>
-                <a:latin typeface="Noto Sans CJK SC"/>
-              </a:defRPr>
-            </a:pPr>
-            <a:r>
-              <a:t>35.8</a:t>
-            </a:r>
-          </a:p>
-        </p:txBody>
-      </p:sp>
-      <p:sp>
-        <p:nvSpPr>
-          <p:cNvPr id="52" name="TextBox 51"/>
-          <p:cNvSpPr txBox="1"/>
-          <p:nvPr/>
-        </p:nvSpPr>
-        <p:spPr>
-          <a:xfrm>
-            <a:off x="685800" y="5541264"/>
-            <a:ext cx="10972800" cy="246888"/>
-          </a:xfrm>
-          <a:prstGeom prst="rect">
-            <a:avLst/>
-          </a:prstGeom>
-          <a:noFill/>
-          <a:effectLst/>
-        </p:spPr>
-        <p:txBody>
-          <a:bodyPr wrap="none" lIns="0" rIns="0" tIns="0" bIns="0">
-            <a:spAutoFit/>
-          </a:bodyPr>
-          <a:lstStyle/>
-          <a:p>
-            <a:pPr>
-              <a:spcAft>
-                <a:spcPts val="700"/>
-              </a:spcAft>
-              <a:defRPr sz="1100" b="0">
-                <a:solidFill>
-                  <a:srgbClr val="62748A"/>
-                </a:solidFill>
-                <a:latin typeface="Noto Sans CJK SC"/>
-              </a:defRPr>
-            </a:pPr>
-            <a:r>
-              <a:t>κ 更低表示预测分布更分散；这些组间差异是相关性证据，不能直接证明因果。</a:t>
-            </a:r>
-          </a:p>
-        </p:txBody>
-      </p:sp>
-      <p:sp>
-        <p:nvSpPr>
-          <p:cNvPr id="53" name="Rounded Rectangle 52"/>
-          <p:cNvSpPr/>
-          <p:nvPr/>
-        </p:nvSpPr>
-        <p:spPr>
-          <a:xfrm>
-            <a:off x="685800" y="5952744"/>
-            <a:ext cx="10826496" cy="448056"/>
-          </a:xfrm>
-          <a:prstGeom prst="roundRect">
-            <a:avLst>
-              <a:gd name="adj" fmla="val 12000"/>
-            </a:avLst>
-          </a:prstGeom>
-          <a:solidFill>
-            <a:srgbClr val="E8F4F2"/>
-          </a:solidFill>
-          <a:ln>
-            <a:noFill/>
-          </a:ln>
-          <a:effectLst/>
-        </p:spPr>
-        <p:style>
-          <a:lnRef idx="1">
-            <a:schemeClr val="accent1"/>
-          </a:lnRef>
-          <a:fillRef idx="3">
-            <a:schemeClr val="accent1"/>
-          </a:fillRef>
-          <a:effectRef idx="0">
-            <a:schemeClr val="accent1"/>
-          </a:effectRef>
-          <a:fontRef idx="minor">
-            <a:schemeClr val="lt1"/>
-          </a:fontRef>
-        </p:style>
-        <p:txBody>
-          <a:bodyPr rtlCol="0" anchor="ctr"/>
-          <a:lstStyle/>
-          <a:p>
-            <a:pPr algn="ctr"/>
-          </a:p>
-        </p:txBody>
-      </p:sp>
-      <p:sp>
-        <p:nvSpPr>
-          <p:cNvPr id="54" name="TextBox 53"/>
+          <p:cNvPr id="50" name="TextBox 49"/>
           <p:cNvSpPr txBox="1"/>
           <p:nvPr/>
         </p:nvSpPr>
@@ -5781,7 +5615,7 @@
       </p:sp>
       <p:cxnSp>
         <p:nvCxnSpPr>
-          <p:cNvPr id="55" name="Connector 54"/>
+          <p:cNvPr id="51" name="Connector 50"/>
           <p:cNvCxnSpPr/>
           <p:nvPr/>
         </p:nvCxnSpPr>
@@ -5817,7 +5651,7 @@
       </p:cxnSp>
       <p:sp>
         <p:nvSpPr>
-          <p:cNvPr id="56" name="TextBox 55"/>
+          <p:cNvPr id="52" name="TextBox 51"/>
           <p:cNvSpPr txBox="1"/>
           <p:nvPr/>
         </p:nvSpPr>
@@ -5857,7 +5691,7 @@
       </p:sp>
       <p:sp>
         <p:nvSpPr>
-          <p:cNvPr id="57" name="TextBox 56"/>
+          <p:cNvPr id="53" name="TextBox 52"/>
           <p:cNvSpPr txBox="1"/>
           <p:nvPr/>
         </p:nvSpPr>

</xml_diff>

<commit_message>
Rewrite slide 05 around matched-cohort motion features and update compiled deck
</commit_message>
<xml_diff>
--- a/presentations/slide05_hard120_analysis_cn.pptx
+++ b/presentations/slide05_hard120_analysis_cn.pptx
@@ -502,37 +502,37 @@
           <a:lstStyle/>
           <a:p>
             <a:r>
-              <a:t>第5页，独立单页文件。来源为main c1b3750的train/logs/revalidation/wp_hard120/summary.txt及enrichment_H_vs_control.csv（control=C_match）。</a:t>
-            </a:r>
-          </a:p>
-          <a:p>
-            <a:r>
-              <a:t>Hard定义为WP bearing error&gt;=45deg，n=120/1000；93.333%为turn_strict。</a:t>
-            </a:r>
-          </a:p>
-          <a:p>
-            <a:r>
-              <a:t>中位数（H vs C_match）：path_winding_8 108.48499999999994 vs 69.43119048174236 deg；past_yaw_rate 14.101111111111116 vs 7.349444444444433；goal_bearing_err_deg 50.399990878953645 vs 15.227550674992074；wp_kappa 8.90623426437378 vs 35.79542350769043。</a:t>
-            </a:r>
-          </a:p>
-          <a:p>
-            <a:r>
-              <a:t>train/analyze_wp_hard120.py:path_kinematics表明past_yaw_rate是过去最多3个采样步的平均绝对yaw变化，并非按秒归一化角速度；本页标为历史平均步间转角，单位deg，不用deg/s。</a:t>
-            </a:r>
-          </a:p>
-          <a:p>
-            <a:r>
-              <a:t>C_match是按turn_strict比例匹配的非hard对照，不是全体其他帧。本页不报告对照样本数：提交的CSV n_C计数与研究设计/当前代码不一致（CSV62770，设计120），无法在缺少原始NPZ时重算；保留与summary.txt一致的中位数并准确标明来源。未据此计算新的置信区间或显著性。</a:t>
-            </a:r>
-          </a:p>
-          <a:p>
-            <a:r>
-              <a:t>四组柱图各自从零起点按本指标最大值定标，不能跨指标比较柱长；所有中位数均来自现有记录，并未重新运行分析。</a:t>
-            </a:r>
-          </a:p>
-          <a:p>
-            <a:r>
-              <a:t>严格转弯标签来自eval_frame_sets.py的turning_mask，对GT横向位移或绝对yaw变化采用OR判定。κ由GoalDirectionHead第三维经softplus+min_kappa得到，标准κ融合直接将该κ用于WP加权；缩放或抑制后得到有效权重，不能称为另一路独立标量。κ是方向分布集中度，较低表明分散程度更高；不采用旧文字结论中“κ更低意味着错还很自信”的错误解释。组间差异只提供历史感知模型的动机，不构成因果证明。</a:t>
+              <a:t>第5页重写：承接收益归因页，问题改为转弯比例相近时困难样本还有哪些运动特征，不再用“错误出现在哪里”的标题承载多个无关特征。</a:t>
+            </a:r>
+          </a:p>
+          <a:p>
+            <a:r>
+              <a:t>来源main c1b3750，train/logs/revalidation/wp_hard120/summary.txt、enrichment_H_vs_control.csv（control=C_match）、train/analyze_wp_hard120.py。</a:t>
+            </a:r>
+          </a:p>
+          <a:p>
+            <a:r>
+              <a:t>Hard为预测WP相对真实8步endpoint方位误差&gt;=45deg，n=120，属于locked1000帧的12%。strict turn=GT endpoint abs(lateral)&gt;=.30m OR abs(yawchange)&gt;=45deg，Hard中占93.333%。C_match从非hard池抽样，匹配strict turn比例93.333%；它并非全部普通帧，也不是所有其他混杂因素均已控制。</a:t>
+            </a:r>
+          </a:p>
+          <a:p>
+            <a:r>
+              <a:t>未来累计绝对转角path_winding_8 med_H108.48499999999994 / med_C69.43119048174236deg（页内108.5/69.4）；历史平均步间转角past_yaw_rate med_H14.101111111111116 / med_C7.349444444444433deg（页内14.10/7.35）。后者是过去最多3采样步绝对yaw变化均值，不是deg/s角速度。</a:t>
+            </a:r>
+          </a:p>
+          <a:p>
+            <a:r>
+              <a:t>比较为中位数，两指标分别从零按120deg和16deg线性刻度画柱。只描述相关特征，不作因果断言。由此提出“视觉历史是否帮助”的可检验假设，下一页P2才给实验回答。</a:t>
+            </a:r>
+          </a:p>
+          <a:p>
+            <a:r>
+              <a:t>Goal方位误差与κ比较从主页面移出，以聚焦引出历史实验的证据；18.3%按此前用户要求不显示。</a:t>
+            </a:r>
+          </a:p>
+          <a:p>
+            <a:r>
+              <a:t>资料限制：CSV n_C与研究设计/当前代码不一致（62770 vs设计120），无法无原始NPZ复算；不报告对照数，采用与summary.txt一致的中位数，不据此计算新显著性。统计来自上传汇总，非本次重跑。</a:t>
             </a:r>
           </a:p>
           <a:p/>
@@ -3670,7 +3670,7 @@
               </a:defRPr>
             </a:pPr>
             <a:r>
-              <a:t>P1b / Hard120 失败样本分析</a:t>
+              <a:t>P1b / 从转弯集中现象，到运动特征对比</a:t>
             </a:r>
           </a:p>
         </p:txBody>
@@ -3710,7 +3710,7 @@
               </a:defRPr>
             </a:pPr>
             <a:r>
-              <a:t>严重航点方向错误，主要出现在哪里？</a:t>
+              <a:t>转弯比例相近时，难例还有什么特点？</a:t>
             </a:r>
           </a:p>
         </p:txBody>
@@ -3742,7 +3742,7 @@
               <a:spcAft>
                 <a:spcPts val="700"/>
               </a:spcAft>
-              <a:defRPr sz="1400" b="0">
+              <a:defRPr sz="1300" b="0">
                 <a:solidFill>
                   <a:srgbClr val="62748A"/>
                 </a:solidFill>
@@ -3750,7 +3750,7 @@
               </a:defRPr>
             </a:pPr>
             <a:r>
-              <a:t>Hard120：WP 角误差 ≥45° 的 120 帧 · 与转弯比例匹配的非 hard 对照比较</a:t>
+              <a:t>承接上一页：严重错误集中在转弯场景；这里进一步比较困难帧与非困难帧的运动特征。</a:t>
             </a:r>
           </a:p>
         </p:txBody>
@@ -3764,7 +3764,7 @@
         <p:spPr>
           <a:xfrm>
             <a:off x="685800" y="2249424"/>
-            <a:ext cx="5303520" cy="832104"/>
+            <a:ext cx="5303520" cy="685800"/>
           </a:xfrm>
           <a:prstGeom prst="roundRect">
             <a:avLst>
@@ -3809,8 +3809,8 @@
         </p:nvSpPr>
         <p:spPr>
           <a:xfrm>
-            <a:off x="832104" y="2340864"/>
-            <a:ext cx="1600200" cy="384048"/>
+            <a:off x="841248" y="2350008"/>
+            <a:ext cx="4983480" cy="265176"/>
           </a:xfrm>
           <a:prstGeom prst="rect">
             <a:avLst/>
@@ -3828,47 +3828,7 @@
               <a:spcAft>
                 <a:spcPts val="700"/>
               </a:spcAft>
-              <a:defRPr sz="2400" b="1">
-                <a:solidFill>
-                  <a:srgbClr val="148D91"/>
-                </a:solidFill>
-                <a:latin typeface="Noto Sans CJK SC"/>
-              </a:defRPr>
-            </a:pPr>
-            <a:r>
-              <a:t>120 帧</a:t>
-            </a:r>
-          </a:p>
-        </p:txBody>
-      </p:sp>
-      <p:sp>
-        <p:nvSpPr>
-          <p:cNvPr id="9" name="TextBox 8"/>
-          <p:cNvSpPr txBox="1"/>
-          <p:nvPr/>
-        </p:nvSpPr>
-        <p:spPr>
-          <a:xfrm>
-            <a:off x="2359152" y="2404872"/>
-            <a:ext cx="3502152" cy="274320"/>
-          </a:xfrm>
-          <a:prstGeom prst="rect">
-            <a:avLst/>
-          </a:prstGeom>
-          <a:noFill/>
-          <a:effectLst/>
-        </p:spPr>
-        <p:txBody>
-          <a:bodyPr wrap="none" lIns="0" rIns="0" tIns="0" bIns="0">
-            <a:spAutoFit/>
-          </a:bodyPr>
-          <a:lstStyle/>
-          <a:p>
-            <a:pPr>
-              <a:spcAft>
-                <a:spcPts val="700"/>
-              </a:spcAft>
-              <a:defRPr sz="1200" b="1">
+              <a:defRPr sz="1400" b="1">
                 <a:solidFill>
                   <a:srgbClr val="142B46"/>
                 </a:solidFill>
@@ -3876,21 +3836,21 @@
               </a:defRPr>
             </a:pPr>
             <a:r>
-              <a:t>WP 方向误差 ≥45° 的困难样本</a:t>
-            </a:r>
-          </a:p>
-        </p:txBody>
-      </p:sp>
-      <p:sp>
-        <p:nvSpPr>
-          <p:cNvPr id="10" name="TextBox 9"/>
+              <a:t>困难组：120 帧</a:t>
+            </a:r>
+          </a:p>
+        </p:txBody>
+      </p:sp>
+      <p:sp>
+        <p:nvSpPr>
+          <p:cNvPr id="9" name="TextBox 8"/>
           <p:cNvSpPr txBox="1"/>
           <p:nvPr/>
         </p:nvSpPr>
         <p:spPr>
           <a:xfrm>
-            <a:off x="832104" y="2825496"/>
-            <a:ext cx="5029200" cy="201168"/>
+            <a:off x="841248" y="2734056"/>
+            <a:ext cx="4983480" cy="210312"/>
           </a:xfrm>
           <a:prstGeom prst="rect">
             <a:avLst/>
@@ -3916,21 +3876,21 @@
               </a:defRPr>
             </a:pPr>
             <a:r>
-              <a:t>预测 WP 与真实终点方向的夹角；占 locked 1000 帧的 12%</a:t>
-            </a:r>
-          </a:p>
-        </p:txBody>
-      </p:sp>
-      <p:sp>
-        <p:nvSpPr>
-          <p:cNvPr id="11" name="Rounded Rectangle 10"/>
+              <a:t>WP 方向误差 ≥45°；其中严格转弯占 93.3%。</a:t>
+            </a:r>
+          </a:p>
+        </p:txBody>
+      </p:sp>
+      <p:sp>
+        <p:nvSpPr>
+          <p:cNvPr id="10" name="Rounded Rectangle 9"/>
           <p:cNvSpPr/>
           <p:nvPr/>
         </p:nvSpPr>
         <p:spPr>
           <a:xfrm>
             <a:off x="6208776" y="2249424"/>
-            <a:ext cx="5303520" cy="832104"/>
+            <a:ext cx="5303520" cy="685800"/>
           </a:xfrm>
           <a:prstGeom prst="roundRect">
             <a:avLst>
@@ -3969,14 +3929,14 @@
       </p:sp>
       <p:sp>
         <p:nvSpPr>
-          <p:cNvPr id="12" name="TextBox 11"/>
+          <p:cNvPr id="11" name="TextBox 10"/>
           <p:cNvSpPr txBox="1"/>
           <p:nvPr/>
         </p:nvSpPr>
         <p:spPr>
           <a:xfrm>
-            <a:off x="6355080" y="2340864"/>
-            <a:ext cx="1600200" cy="384048"/>
+            <a:off x="6364224" y="2350008"/>
+            <a:ext cx="4983480" cy="265176"/>
           </a:xfrm>
           <a:prstGeom prst="rect">
             <a:avLst/>
@@ -3994,47 +3954,7 @@
               <a:spcAft>
                 <a:spcPts val="700"/>
               </a:spcAft>
-              <a:defRPr sz="2400" b="1">
-                <a:solidFill>
-                  <a:srgbClr val="148D91"/>
-                </a:solidFill>
-                <a:latin typeface="Noto Sans CJK SC"/>
-              </a:defRPr>
-            </a:pPr>
-            <a:r>
-              <a:t>93.3%</a:t>
-            </a:r>
-          </a:p>
-        </p:txBody>
-      </p:sp>
-      <p:sp>
-        <p:nvSpPr>
-          <p:cNvPr id="13" name="TextBox 12"/>
-          <p:cNvSpPr txBox="1"/>
-          <p:nvPr/>
-        </p:nvSpPr>
-        <p:spPr>
-          <a:xfrm>
-            <a:off x="7882128" y="2404872"/>
-            <a:ext cx="3502152" cy="274320"/>
-          </a:xfrm>
-          <a:prstGeom prst="rect">
-            <a:avLst/>
-          </a:prstGeom>
-          <a:noFill/>
-          <a:effectLst/>
-        </p:spPr>
-        <p:txBody>
-          <a:bodyPr wrap="none" lIns="0" rIns="0" tIns="0" bIns="0">
-            <a:spAutoFit/>
-          </a:bodyPr>
-          <a:lstStyle/>
-          <a:p>
-            <a:pPr>
-              <a:spcAft>
-                <a:spcPts val="700"/>
-              </a:spcAft>
-              <a:defRPr sz="1200" b="1">
+              <a:defRPr sz="1400" b="1">
                 <a:solidFill>
                   <a:srgbClr val="142B46"/>
                 </a:solidFill>
@@ -4042,21 +3962,21 @@
               </a:defRPr>
             </a:pPr>
             <a:r>
-              <a:t>困难样本属于严格转弯</a:t>
-            </a:r>
-          </a:p>
-        </p:txBody>
-      </p:sp>
-      <p:sp>
-        <p:nvSpPr>
-          <p:cNvPr id="14" name="TextBox 13"/>
+              <a:t>对照组：从非困难帧中选取</a:t>
+            </a:r>
+          </a:p>
+        </p:txBody>
+      </p:sp>
+      <p:sp>
+        <p:nvSpPr>
+          <p:cNvPr id="12" name="TextBox 11"/>
           <p:cNvSpPr txBox="1"/>
           <p:nvPr/>
         </p:nvSpPr>
         <p:spPr>
           <a:xfrm>
-            <a:off x="6355080" y="2825496"/>
-            <a:ext cx="5029200" cy="201168"/>
+            <a:off x="6364224" y="2734056"/>
+            <a:ext cx="4983480" cy="210312"/>
           </a:xfrm>
           <a:prstGeom prst="rect">
             <a:avLst/>
@@ -4082,67 +4002,29 @@
               </a:defRPr>
             </a:pPr>
             <a:r>
-              <a:t>GT 判定：|横向位移| ≥0.30 m 或 |航向变化| ≥45°</a:t>
-            </a:r>
-          </a:p>
-        </p:txBody>
-      </p:sp>
-      <p:sp>
-        <p:nvSpPr>
-          <p:cNvPr id="15" name="TextBox 14"/>
-          <p:cNvSpPr txBox="1"/>
-          <p:nvPr/>
-        </p:nvSpPr>
-        <p:spPr>
-          <a:xfrm>
-            <a:off x="685800" y="3291840"/>
-            <a:ext cx="6400800" cy="256032"/>
-          </a:xfrm>
-          <a:prstGeom prst="rect">
-            <a:avLst/>
-          </a:prstGeom>
-          <a:noFill/>
-          <a:effectLst/>
-        </p:spPr>
-        <p:txBody>
-          <a:bodyPr wrap="none" lIns="0" rIns="0" tIns="0" bIns="0">
-            <a:spAutoFit/>
-          </a:bodyPr>
-          <a:lstStyle/>
-          <a:p>
-            <a:pPr>
-              <a:spcAft>
-                <a:spcPts val="700"/>
-              </a:spcAft>
-              <a:defRPr sz="1500" b="1">
-                <a:solidFill>
-                  <a:srgbClr val="142B46"/>
-                </a:solidFill>
-                <a:latin typeface="Noto Sans CJK SC"/>
-              </a:defRPr>
-            </a:pPr>
-            <a:r>
-              <a:t>特征对比：困难组 vs 匹配对照（中位数）</a:t>
-            </a:r>
-          </a:p>
-        </p:txBody>
-      </p:sp>
-      <p:sp>
-        <p:nvSpPr>
-          <p:cNvPr id="16" name="Rectangle 15"/>
+              <a:t>匹配转弯占比为 93.3%，减少弯道与直道差异的影响。</a:t>
+            </a:r>
+          </a:p>
+        </p:txBody>
+      </p:sp>
+      <p:sp>
+        <p:nvSpPr>
+          <p:cNvPr id="13" name="Rounded Rectangle 12"/>
           <p:cNvSpPr/>
           <p:nvPr/>
         </p:nvSpPr>
         <p:spPr>
           <a:xfrm>
-            <a:off x="8330183" y="3328416"/>
-            <a:ext cx="155448" cy="118872"/>
-          </a:xfrm>
-          <a:prstGeom prst="rect">
-            <a:avLst/>
+            <a:off x="685800" y="3310128"/>
+            <a:ext cx="5303520" cy="2276856"/>
+          </a:xfrm>
+          <a:prstGeom prst="roundRect">
+            <a:avLst>
+              <a:gd name="adj" fmla="val 12000"/>
+            </a:avLst>
           </a:prstGeom>
           <a:solidFill>
-            <a:srgbClr val="148D91"/>
+            <a:srgbClr val="F0F4F8"/>
           </a:solidFill>
           <a:ln>
             <a:noFill/>
@@ -4173,14 +4055,14 @@
       </p:sp>
       <p:sp>
         <p:nvSpPr>
-          <p:cNvPr id="17" name="TextBox 16"/>
+          <p:cNvPr id="14" name="TextBox 13"/>
           <p:cNvSpPr txBox="1"/>
           <p:nvPr/>
         </p:nvSpPr>
         <p:spPr>
           <a:xfrm>
-            <a:off x="8577072" y="3264408"/>
-            <a:ext cx="1188720" cy="228600"/>
+            <a:off x="850392" y="3456432"/>
+            <a:ext cx="4937760" cy="329184"/>
           </a:xfrm>
           <a:prstGeom prst="rect">
             <a:avLst/>
@@ -4198,7 +4080,47 @@
               <a:spcAft>
                 <a:spcPts val="700"/>
               </a:spcAft>
-              <a:defRPr sz="1000" b="0">
+              <a:defRPr sz="2000" b="1">
+                <a:solidFill>
+                  <a:srgbClr val="148D91"/>
+                </a:solidFill>
+                <a:latin typeface="Noto Sans CJK SC"/>
+              </a:defRPr>
+            </a:pPr>
+            <a:r>
+              <a:t>① 未来路径更弯</a:t>
+            </a:r>
+          </a:p>
+        </p:txBody>
+      </p:sp>
+      <p:sp>
+        <p:nvSpPr>
+          <p:cNvPr id="15" name="TextBox 14"/>
+          <p:cNvSpPr txBox="1"/>
+          <p:nvPr/>
+        </p:nvSpPr>
+        <p:spPr>
+          <a:xfrm>
+            <a:off x="850392" y="3922776"/>
+            <a:ext cx="4937760" cy="246888"/>
+          </a:xfrm>
+          <a:prstGeom prst="rect">
+            <a:avLst/>
+          </a:prstGeom>
+          <a:noFill/>
+          <a:effectLst/>
+        </p:spPr>
+        <p:txBody>
+          <a:bodyPr wrap="none" lIns="0" rIns="0" tIns="0" bIns="0">
+            <a:spAutoFit/>
+          </a:bodyPr>
+          <a:lstStyle/>
+          <a:p>
+            <a:pPr>
+              <a:spcAft>
+                <a:spcPts val="700"/>
+              </a:spcAft>
+              <a:defRPr sz="1200" b="0">
                 <a:solidFill>
                   <a:srgbClr val="62748A"/>
                 </a:solidFill>
@@ -4206,27 +4128,69 @@
               </a:defRPr>
             </a:pPr>
             <a:r>
-              <a:t>困难组</a:t>
-            </a:r>
-          </a:p>
-        </p:txBody>
-      </p:sp>
-      <p:sp>
-        <p:nvSpPr>
-          <p:cNvPr id="18" name="Rectangle 17"/>
-          <p:cNvSpPr/>
+              <a:t>未来 8 步累计绝对转角（中位数）</a:t>
+            </a:r>
+          </a:p>
+        </p:txBody>
+      </p:sp>
+      <p:sp>
+        <p:nvSpPr>
+          <p:cNvPr id="16" name="TextBox 15"/>
+          <p:cNvSpPr txBox="1"/>
           <p:nvPr/>
         </p:nvSpPr>
         <p:spPr>
           <a:xfrm>
-            <a:off x="9857232" y="3328416"/>
-            <a:ext cx="155448" cy="118872"/>
+            <a:off x="850392" y="4393692"/>
+            <a:ext cx="822960" cy="237744"/>
           </a:xfrm>
           <a:prstGeom prst="rect">
             <a:avLst/>
           </a:prstGeom>
+          <a:noFill/>
+          <a:effectLst/>
+        </p:spPr>
+        <p:txBody>
+          <a:bodyPr wrap="none" lIns="0" rIns="0" tIns="0" bIns="0">
+            <a:spAutoFit/>
+          </a:bodyPr>
+          <a:lstStyle/>
+          <a:p>
+            <a:pPr>
+              <a:spcAft>
+                <a:spcPts val="700"/>
+              </a:spcAft>
+              <a:defRPr sz="1100" b="0">
+                <a:solidFill>
+                  <a:srgbClr val="62748A"/>
+                </a:solidFill>
+                <a:latin typeface="Noto Sans CJK SC"/>
+              </a:defRPr>
+            </a:pPr>
+            <a:r>
+              <a:t>困难组</a:t>
+            </a:r>
+          </a:p>
+        </p:txBody>
+      </p:sp>
+      <p:sp>
+        <p:nvSpPr>
+          <p:cNvPr id="17" name="Rounded Rectangle 16"/>
+          <p:cNvSpPr/>
+          <p:nvPr/>
+        </p:nvSpPr>
+        <p:spPr>
+          <a:xfrm>
+            <a:off x="1755648" y="4443984"/>
+            <a:ext cx="2761030" cy="182880"/>
+          </a:xfrm>
+          <a:prstGeom prst="roundRect">
+            <a:avLst>
+              <a:gd name="adj" fmla="val 12000"/>
+            </a:avLst>
+          </a:prstGeom>
           <a:solidFill>
-            <a:srgbClr val="9CB5D8"/>
+            <a:srgbClr val="148D91"/>
           </a:solidFill>
           <a:ln>
             <a:noFill/>
@@ -4257,14 +4221,14 @@
       </p:sp>
       <p:sp>
         <p:nvSpPr>
-          <p:cNvPr id="19" name="TextBox 18"/>
+          <p:cNvPr id="18" name="TextBox 17"/>
           <p:cNvSpPr txBox="1"/>
           <p:nvPr/>
         </p:nvSpPr>
         <p:spPr>
           <a:xfrm>
-            <a:off x="10104120" y="3264408"/>
-            <a:ext cx="1371600" cy="228600"/>
+            <a:off x="4946904" y="4343400"/>
+            <a:ext cx="896112" cy="301752"/>
           </a:xfrm>
           <a:prstGeom prst="rect">
             <a:avLst/>
@@ -4282,7 +4246,47 @@
               <a:spcAft>
                 <a:spcPts val="700"/>
               </a:spcAft>
-              <a:defRPr sz="1000" b="0">
+              <a:defRPr sz="1700" b="1">
+                <a:solidFill>
+                  <a:srgbClr val="148D91"/>
+                </a:solidFill>
+                <a:latin typeface="Noto Sans CJK SC"/>
+              </a:defRPr>
+            </a:pPr>
+            <a:r>
+              <a:t>108.5°</a:t>
+            </a:r>
+          </a:p>
+        </p:txBody>
+      </p:sp>
+      <p:sp>
+        <p:nvSpPr>
+          <p:cNvPr id="19" name="TextBox 18"/>
+          <p:cNvSpPr txBox="1"/>
+          <p:nvPr/>
+        </p:nvSpPr>
+        <p:spPr>
+          <a:xfrm>
+            <a:off x="850392" y="4832604"/>
+            <a:ext cx="822960" cy="237744"/>
+          </a:xfrm>
+          <a:prstGeom prst="rect">
+            <a:avLst/>
+          </a:prstGeom>
+          <a:noFill/>
+          <a:effectLst/>
+        </p:spPr>
+        <p:txBody>
+          <a:bodyPr wrap="none" lIns="0" rIns="0" tIns="0" bIns="0">
+            <a:spAutoFit/>
+          </a:bodyPr>
+          <a:lstStyle/>
+          <a:p>
+            <a:pPr>
+              <a:spcAft>
+                <a:spcPts val="700"/>
+              </a:spcAft>
+              <a:defRPr sz="1100" b="0">
                 <a:solidFill>
                   <a:srgbClr val="62748A"/>
                 </a:solidFill>
@@ -4290,7 +4294,7 @@
               </a:defRPr>
             </a:pPr>
             <a:r>
-              <a:t>匹配对照</a:t>
+              <a:t>对照组</a:t>
             </a:r>
           </a:p>
         </p:txBody>
@@ -4303,8 +4307,8 @@
         </p:nvSpPr>
         <p:spPr>
           <a:xfrm>
-            <a:off x="685800" y="3675887"/>
-            <a:ext cx="2542032" cy="1728216"/>
+            <a:off x="1755648" y="4882896"/>
+            <a:ext cx="1767079" cy="182880"/>
           </a:xfrm>
           <a:prstGeom prst="roundRect">
             <a:avLst>
@@ -4312,7 +4316,7 @@
             </a:avLst>
           </a:prstGeom>
           <a:solidFill>
-            <a:srgbClr val="F0F4F8"/>
+            <a:srgbClr val="9CB5D8"/>
           </a:solidFill>
           <a:ln>
             <a:noFill/>
@@ -4349,8 +4353,8 @@
         </p:nvSpPr>
         <p:spPr>
           <a:xfrm>
-            <a:off x="822960" y="3831336"/>
-            <a:ext cx="2286000" cy="283464"/>
+            <a:off x="4946904" y="4782312"/>
+            <a:ext cx="896112" cy="301752"/>
           </a:xfrm>
           <a:prstGeom prst="rect">
             <a:avLst/>
@@ -4368,15 +4372,15 @@
               <a:spcAft>
                 <a:spcPts val="700"/>
               </a:spcAft>
-              <a:defRPr sz="1300" b="1">
+              <a:defRPr sz="1700" b="1">
                 <a:solidFill>
-                  <a:srgbClr val="142B46"/>
+                  <a:srgbClr val="62748A"/>
                 </a:solidFill>
                 <a:latin typeface="Noto Sans CJK SC"/>
               </a:defRPr>
             </a:pPr>
             <a:r>
-              <a:t>未来 8 步累计转角</a:t>
+              <a:t>69.4°</a:t>
             </a:r>
           </a:p>
         </p:txBody>
@@ -4389,8 +4393,8 @@
         </p:nvSpPr>
         <p:spPr>
           <a:xfrm>
-            <a:off x="822960" y="4187952"/>
-            <a:ext cx="2286000" cy="237744"/>
+            <a:off x="850392" y="5285232"/>
+            <a:ext cx="4937760" cy="219456"/>
           </a:xfrm>
           <a:prstGeom prst="rect">
             <a:avLst/>
@@ -4416,7 +4420,7 @@
               </a:defRPr>
             </a:pPr>
             <a:r>
-              <a:t>路径弯曲程度</a:t>
+              <a:t>每步转了多少角度，取绝对值后累加。</a:t>
             </a:r>
           </a:p>
         </p:txBody>
@@ -4429,8 +4433,8 @@
         </p:nvSpPr>
         <p:spPr>
           <a:xfrm>
-            <a:off x="822960" y="4668012"/>
-            <a:ext cx="1320800" cy="146304"/>
+            <a:off x="6208776" y="3310128"/>
+            <a:ext cx="5303520" cy="2276856"/>
           </a:xfrm>
           <a:prstGeom prst="roundRect">
             <a:avLst>
@@ -4438,7 +4442,7 @@
             </a:avLst>
           </a:prstGeom>
           <a:solidFill>
-            <a:srgbClr val="148D91"/>
+            <a:srgbClr val="F0F4F8"/>
           </a:solidFill>
           <a:ln>
             <a:noFill/>
@@ -4475,8 +4479,8 @@
         </p:nvSpPr>
         <p:spPr>
           <a:xfrm>
-            <a:off x="2340864" y="4576572"/>
-            <a:ext cx="813816" cy="292608"/>
+            <a:off x="6373368" y="3456432"/>
+            <a:ext cx="4937760" cy="329184"/>
           </a:xfrm>
           <a:prstGeom prst="rect">
             <a:avLst/>
@@ -4494,7 +4498,7 @@
               <a:spcAft>
                 <a:spcPts val="700"/>
               </a:spcAft>
-              <a:defRPr sz="1400" b="1">
+              <a:defRPr sz="2000" b="1">
                 <a:solidFill>
                   <a:srgbClr val="148D91"/>
                 </a:solidFill>
@@ -4502,21 +4506,101 @@
               </a:defRPr>
             </a:pPr>
             <a:r>
-              <a:t>108.5°</a:t>
-            </a:r>
-          </a:p>
-        </p:txBody>
-      </p:sp>
-      <p:sp>
-        <p:nvSpPr>
-          <p:cNvPr id="25" name="Rounded Rectangle 24"/>
+              <a:t>② 近期旋转更强</a:t>
+            </a:r>
+          </a:p>
+        </p:txBody>
+      </p:sp>
+      <p:sp>
+        <p:nvSpPr>
+          <p:cNvPr id="25" name="TextBox 24"/>
+          <p:cNvSpPr txBox="1"/>
+          <p:nvPr/>
+        </p:nvSpPr>
+        <p:spPr>
+          <a:xfrm>
+            <a:off x="6373368" y="3922776"/>
+            <a:ext cx="4937760" cy="246888"/>
+          </a:xfrm>
+          <a:prstGeom prst="rect">
+            <a:avLst/>
+          </a:prstGeom>
+          <a:noFill/>
+          <a:effectLst/>
+        </p:spPr>
+        <p:txBody>
+          <a:bodyPr wrap="none" lIns="0" rIns="0" tIns="0" bIns="0">
+            <a:spAutoFit/>
+          </a:bodyPr>
+          <a:lstStyle/>
+          <a:p>
+            <a:pPr>
+              <a:spcAft>
+                <a:spcPts val="700"/>
+              </a:spcAft>
+              <a:defRPr sz="1200" b="0">
+                <a:solidFill>
+                  <a:srgbClr val="62748A"/>
+                </a:solidFill>
+                <a:latin typeface="Noto Sans CJK SC"/>
+              </a:defRPr>
+            </a:pPr>
+            <a:r>
+              <a:t>历史平均步间转角（中位数）</a:t>
+            </a:r>
+          </a:p>
+        </p:txBody>
+      </p:sp>
+      <p:sp>
+        <p:nvSpPr>
+          <p:cNvPr id="26" name="TextBox 25"/>
+          <p:cNvSpPr txBox="1"/>
+          <p:nvPr/>
+        </p:nvSpPr>
+        <p:spPr>
+          <a:xfrm>
+            <a:off x="6373368" y="4393692"/>
+            <a:ext cx="822960" cy="237744"/>
+          </a:xfrm>
+          <a:prstGeom prst="rect">
+            <a:avLst/>
+          </a:prstGeom>
+          <a:noFill/>
+          <a:effectLst/>
+        </p:spPr>
+        <p:txBody>
+          <a:bodyPr wrap="none" lIns="0" rIns="0" tIns="0" bIns="0">
+            <a:spAutoFit/>
+          </a:bodyPr>
+          <a:lstStyle/>
+          <a:p>
+            <a:pPr>
+              <a:spcAft>
+                <a:spcPts val="700"/>
+              </a:spcAft>
+              <a:defRPr sz="1100" b="0">
+                <a:solidFill>
+                  <a:srgbClr val="62748A"/>
+                </a:solidFill>
+                <a:latin typeface="Noto Sans CJK SC"/>
+              </a:defRPr>
+            </a:pPr>
+            <a:r>
+              <a:t>困难组</a:t>
+            </a:r>
+          </a:p>
+        </p:txBody>
+      </p:sp>
+      <p:sp>
+        <p:nvSpPr>
+          <p:cNvPr id="27" name="Rounded Rectangle 26"/>
           <p:cNvSpPr/>
           <p:nvPr/>
         </p:nvSpPr>
         <p:spPr>
           <a:xfrm>
-            <a:off x="822960" y="5052060"/>
-            <a:ext cx="845321" cy="146304"/>
+            <a:off x="7278624" y="4443984"/>
+            <a:ext cx="2691634" cy="182880"/>
           </a:xfrm>
           <a:prstGeom prst="roundRect">
             <a:avLst>
@@ -4524,7 +4608,7 @@
             </a:avLst>
           </a:prstGeom>
           <a:solidFill>
-            <a:srgbClr val="9CB5D8"/>
+            <a:srgbClr val="148D91"/>
           </a:solidFill>
           <a:ln>
             <a:noFill/>
@@ -4555,14 +4639,14 @@
       </p:sp>
       <p:sp>
         <p:nvSpPr>
-          <p:cNvPr id="26" name="TextBox 25"/>
+          <p:cNvPr id="28" name="TextBox 27"/>
           <p:cNvSpPr txBox="1"/>
           <p:nvPr/>
         </p:nvSpPr>
         <p:spPr>
           <a:xfrm>
-            <a:off x="2340864" y="4960620"/>
-            <a:ext cx="813816" cy="292608"/>
+            <a:off x="10469880" y="4343400"/>
+            <a:ext cx="896112" cy="301752"/>
           </a:xfrm>
           <a:prstGeom prst="rect">
             <a:avLst/>
@@ -4580,7 +4664,47 @@
               <a:spcAft>
                 <a:spcPts val="700"/>
               </a:spcAft>
-              <a:defRPr sz="1400" b="1">
+              <a:defRPr sz="1700" b="1">
+                <a:solidFill>
+                  <a:srgbClr val="148D91"/>
+                </a:solidFill>
+                <a:latin typeface="Noto Sans CJK SC"/>
+              </a:defRPr>
+            </a:pPr>
+            <a:r>
+              <a:t>14.10°</a:t>
+            </a:r>
+          </a:p>
+        </p:txBody>
+      </p:sp>
+      <p:sp>
+        <p:nvSpPr>
+          <p:cNvPr id="29" name="TextBox 28"/>
+          <p:cNvSpPr txBox="1"/>
+          <p:nvPr/>
+        </p:nvSpPr>
+        <p:spPr>
+          <a:xfrm>
+            <a:off x="6373368" y="4832604"/>
+            <a:ext cx="822960" cy="237744"/>
+          </a:xfrm>
+          <a:prstGeom prst="rect">
+            <a:avLst/>
+          </a:prstGeom>
+          <a:noFill/>
+          <a:effectLst/>
+        </p:spPr>
+        <p:txBody>
+          <a:bodyPr wrap="none" lIns="0" rIns="0" tIns="0" bIns="0">
+            <a:spAutoFit/>
+          </a:bodyPr>
+          <a:lstStyle/>
+          <a:p>
+            <a:pPr>
+              <a:spcAft>
+                <a:spcPts val="700"/>
+              </a:spcAft>
+              <a:defRPr sz="1100" b="0">
                 <a:solidFill>
                   <a:srgbClr val="62748A"/>
                 </a:solidFill>
@@ -4588,21 +4712,21 @@
               </a:defRPr>
             </a:pPr>
             <a:r>
-              <a:t>69.4°</a:t>
-            </a:r>
-          </a:p>
-        </p:txBody>
-      </p:sp>
-      <p:sp>
-        <p:nvSpPr>
-          <p:cNvPr id="27" name="Rounded Rectangle 26"/>
+              <a:t>对照组</a:t>
+            </a:r>
+          </a:p>
+        </p:txBody>
+      </p:sp>
+      <p:sp>
+        <p:nvSpPr>
+          <p:cNvPr id="30" name="Rounded Rectangle 29"/>
           <p:cNvSpPr/>
           <p:nvPr/>
         </p:nvSpPr>
         <p:spPr>
           <a:xfrm>
-            <a:off x="3447288" y="3675887"/>
-            <a:ext cx="2542032" cy="1728216"/>
+            <a:off x="7278624" y="4882896"/>
+            <a:ext cx="1402869" cy="182880"/>
           </a:xfrm>
           <a:prstGeom prst="roundRect">
             <a:avLst>
@@ -4610,7 +4734,7 @@
             </a:avLst>
           </a:prstGeom>
           <a:solidFill>
-            <a:srgbClr val="F0F4F8"/>
+            <a:srgbClr val="9CB5D8"/>
           </a:solidFill>
           <a:ln>
             <a:noFill/>
@@ -4641,14 +4765,14 @@
       </p:sp>
       <p:sp>
         <p:nvSpPr>
-          <p:cNvPr id="28" name="TextBox 27"/>
+          <p:cNvPr id="31" name="TextBox 30"/>
           <p:cNvSpPr txBox="1"/>
           <p:nvPr/>
         </p:nvSpPr>
         <p:spPr>
           <a:xfrm>
-            <a:off x="3584448" y="3831336"/>
-            <a:ext cx="2286000" cy="283464"/>
+            <a:off x="10469880" y="4782312"/>
+            <a:ext cx="896112" cy="301752"/>
           </a:xfrm>
           <a:prstGeom prst="rect">
             <a:avLst/>
@@ -4666,29 +4790,29 @@
               <a:spcAft>
                 <a:spcPts val="700"/>
               </a:spcAft>
-              <a:defRPr sz="1300" b="1">
+              <a:defRPr sz="1700" b="1">
                 <a:solidFill>
-                  <a:srgbClr val="142B46"/>
+                  <a:srgbClr val="62748A"/>
                 </a:solidFill>
                 <a:latin typeface="Noto Sans CJK SC"/>
               </a:defRPr>
             </a:pPr>
             <a:r>
-              <a:t>历史平均步间转角</a:t>
-            </a:r>
-          </a:p>
-        </p:txBody>
-      </p:sp>
-      <p:sp>
-        <p:nvSpPr>
-          <p:cNvPr id="29" name="TextBox 28"/>
+              <a:t>7.35°</a:t>
+            </a:r>
+          </a:p>
+        </p:txBody>
+      </p:sp>
+      <p:sp>
+        <p:nvSpPr>
+          <p:cNvPr id="32" name="TextBox 31"/>
           <p:cNvSpPr txBox="1"/>
           <p:nvPr/>
         </p:nvSpPr>
         <p:spPr>
           <a:xfrm>
-            <a:off x="3584448" y="4187952"/>
-            <a:ext cx="2286000" cy="237744"/>
+            <a:off x="6373368" y="5285232"/>
+            <a:ext cx="4937760" cy="219456"/>
           </a:xfrm>
           <a:prstGeom prst="rect">
             <a:avLst/>
@@ -4714,21 +4838,61 @@
               </a:defRPr>
             </a:pPr>
             <a:r>
-              <a:t>过去 3 步的 |Δyaw| 均值</a:t>
-            </a:r>
-          </a:p>
-        </p:txBody>
-      </p:sp>
-      <p:sp>
-        <p:nvSpPr>
-          <p:cNvPr id="30" name="Rounded Rectangle 29"/>
+              <a:t>过去 3 步绝对航向变化的均值。</a:t>
+            </a:r>
+          </a:p>
+        </p:txBody>
+      </p:sp>
+      <p:sp>
+        <p:nvSpPr>
+          <p:cNvPr id="33" name="TextBox 32"/>
+          <p:cNvSpPr txBox="1"/>
+          <p:nvPr/>
+        </p:nvSpPr>
+        <p:spPr>
+          <a:xfrm>
+            <a:off x="685800" y="5806440"/>
+            <a:ext cx="10826496" cy="265176"/>
+          </a:xfrm>
+          <a:prstGeom prst="rect">
+            <a:avLst/>
+          </a:prstGeom>
+          <a:noFill/>
+          <a:effectLst/>
+        </p:spPr>
+        <p:txBody>
+          <a:bodyPr wrap="none" lIns="0" rIns="0" tIns="0" bIns="0">
+            <a:spAutoFit/>
+          </a:bodyPr>
+          <a:lstStyle/>
+          <a:p>
+            <a:pPr>
+              <a:spcAft>
+                <a:spcPts val="700"/>
+              </a:spcAft>
+              <a:defRPr sz="1000" b="0">
+                <a:solidFill>
+                  <a:srgbClr val="62748A"/>
+                </a:solidFill>
+                <a:latin typeface="Noto Sans CJK SC"/>
+              </a:defRPr>
+            </a:pPr>
+            <a:r>
+              <a:t>这些是组间相关特征；对照只匹配了转弯比例，尚不能证明近期旋转或路径弯曲导致预测错误。</a:t>
+            </a:r>
+          </a:p>
+        </p:txBody>
+      </p:sp>
+      <p:sp>
+        <p:nvSpPr>
+          <p:cNvPr id="34" name="Rounded Rectangle 33"/>
           <p:cNvSpPr/>
           <p:nvPr/>
         </p:nvSpPr>
         <p:spPr>
           <a:xfrm>
-            <a:off x="3584448" y="4668012"/>
-            <a:ext cx="1320800" cy="146304"/>
+            <a:off x="685800" y="6199632"/>
+            <a:ext cx="10826496" cy="411480"/>
           </a:xfrm>
           <a:prstGeom prst="roundRect">
             <a:avLst>
@@ -4736,7 +4900,7 @@
             </a:avLst>
           </a:prstGeom>
           <a:solidFill>
-            <a:srgbClr val="148D91"/>
+            <a:srgbClr val="E8F4F2"/>
           </a:solidFill>
           <a:ln>
             <a:noFill/>
@@ -4767,14 +4931,14 @@
       </p:sp>
       <p:sp>
         <p:nvSpPr>
-          <p:cNvPr id="31" name="TextBox 30"/>
+          <p:cNvPr id="35" name="TextBox 34"/>
           <p:cNvSpPr txBox="1"/>
           <p:nvPr/>
         </p:nvSpPr>
         <p:spPr>
           <a:xfrm>
-            <a:off x="5102352" y="4576572"/>
-            <a:ext cx="813816" cy="292608"/>
+            <a:off x="859536" y="6272784"/>
+            <a:ext cx="10424160" cy="265176"/>
           </a:xfrm>
           <a:prstGeom prst="rect">
             <a:avLst/>
@@ -4792,7 +4956,7 @@
               <a:spcAft>
                 <a:spcPts val="700"/>
               </a:spcAft>
-              <a:defRPr sz="1400" b="1">
+              <a:defRPr sz="1300" b="1">
                 <a:solidFill>
                   <a:srgbClr val="148D91"/>
                 </a:solidFill>
@@ -4800,179 +4964,7 @@
               </a:defRPr>
             </a:pPr>
             <a:r>
-              <a:t>14.1°</a:t>
-            </a:r>
-          </a:p>
-        </p:txBody>
-      </p:sp>
-      <p:sp>
-        <p:nvSpPr>
-          <p:cNvPr id="32" name="Rounded Rectangle 31"/>
-          <p:cNvSpPr/>
-          <p:nvPr/>
-        </p:nvSpPr>
-        <p:spPr>
-          <a:xfrm>
-            <a:off x="3584448" y="5052060"/>
-            <a:ext cx="688395" cy="146304"/>
-          </a:xfrm>
-          <a:prstGeom prst="roundRect">
-            <a:avLst>
-              <a:gd name="adj" fmla="val 12000"/>
-            </a:avLst>
-          </a:prstGeom>
-          <a:solidFill>
-            <a:srgbClr val="9CB5D8"/>
-          </a:solidFill>
-          <a:ln>
-            <a:noFill/>
-          </a:ln>
-          <a:effectLst/>
-        </p:spPr>
-        <p:style>
-          <a:lnRef idx="1">
-            <a:schemeClr val="accent1"/>
-          </a:lnRef>
-          <a:fillRef idx="3">
-            <a:schemeClr val="accent1"/>
-          </a:fillRef>
-          <a:effectRef idx="0">
-            <a:schemeClr val="accent1"/>
-          </a:effectRef>
-          <a:fontRef idx="minor">
-            <a:schemeClr val="lt1"/>
-          </a:fontRef>
-        </p:style>
-        <p:txBody>
-          <a:bodyPr rtlCol="0" anchor="ctr"/>
-          <a:lstStyle/>
-          <a:p>
-            <a:pPr algn="ctr"/>
-          </a:p>
-        </p:txBody>
-      </p:sp>
-      <p:sp>
-        <p:nvSpPr>
-          <p:cNvPr id="33" name="TextBox 32"/>
-          <p:cNvSpPr txBox="1"/>
-          <p:nvPr/>
-        </p:nvSpPr>
-        <p:spPr>
-          <a:xfrm>
-            <a:off x="5102352" y="4960620"/>
-            <a:ext cx="813816" cy="292608"/>
-          </a:xfrm>
-          <a:prstGeom prst="rect">
-            <a:avLst/>
-          </a:prstGeom>
-          <a:noFill/>
-          <a:effectLst/>
-        </p:spPr>
-        <p:txBody>
-          <a:bodyPr wrap="none" lIns="0" rIns="0" tIns="0" bIns="0">
-            <a:spAutoFit/>
-          </a:bodyPr>
-          <a:lstStyle/>
-          <a:p>
-            <a:pPr>
-              <a:spcAft>
-                <a:spcPts val="700"/>
-              </a:spcAft>
-              <a:defRPr sz="1400" b="1">
-                <a:solidFill>
-                  <a:srgbClr val="62748A"/>
-                </a:solidFill>
-                <a:latin typeface="Noto Sans CJK SC"/>
-              </a:defRPr>
-            </a:pPr>
-            <a:r>
-              <a:t>7.3°</a:t>
-            </a:r>
-          </a:p>
-        </p:txBody>
-      </p:sp>
-      <p:sp>
-        <p:nvSpPr>
-          <p:cNvPr id="34" name="Rounded Rectangle 33"/>
-          <p:cNvSpPr/>
-          <p:nvPr/>
-        </p:nvSpPr>
-        <p:spPr>
-          <a:xfrm>
-            <a:off x="6208776" y="3675887"/>
-            <a:ext cx="2542032" cy="1728216"/>
-          </a:xfrm>
-          <a:prstGeom prst="roundRect">
-            <a:avLst>
-              <a:gd name="adj" fmla="val 12000"/>
-            </a:avLst>
-          </a:prstGeom>
-          <a:solidFill>
-            <a:srgbClr val="F0F4F8"/>
-          </a:solidFill>
-          <a:ln>
-            <a:noFill/>
-          </a:ln>
-          <a:effectLst/>
-        </p:spPr>
-        <p:style>
-          <a:lnRef idx="1">
-            <a:schemeClr val="accent1"/>
-          </a:lnRef>
-          <a:fillRef idx="3">
-            <a:schemeClr val="accent1"/>
-          </a:fillRef>
-          <a:effectRef idx="0">
-            <a:schemeClr val="accent1"/>
-          </a:effectRef>
-          <a:fontRef idx="minor">
-            <a:schemeClr val="lt1"/>
-          </a:fontRef>
-        </p:style>
-        <p:txBody>
-          <a:bodyPr rtlCol="0" anchor="ctr"/>
-          <a:lstStyle/>
-          <a:p>
-            <a:pPr algn="ctr"/>
-          </a:p>
-        </p:txBody>
-      </p:sp>
-      <p:sp>
-        <p:nvSpPr>
-          <p:cNvPr id="35" name="TextBox 34"/>
-          <p:cNvSpPr txBox="1"/>
-          <p:nvPr/>
-        </p:nvSpPr>
-        <p:spPr>
-          <a:xfrm>
-            <a:off x="6345936" y="3831336"/>
-            <a:ext cx="2286000" cy="283464"/>
-          </a:xfrm>
-          <a:prstGeom prst="rect">
-            <a:avLst/>
-          </a:prstGeom>
-          <a:noFill/>
-          <a:effectLst/>
-        </p:spPr>
-        <p:txBody>
-          <a:bodyPr wrap="none" lIns="0" rIns="0" tIns="0" bIns="0">
-            <a:spAutoFit/>
-          </a:bodyPr>
-          <a:lstStyle/>
-          <a:p>
-            <a:pPr>
-              <a:spcAft>
-                <a:spcPts val="700"/>
-              </a:spcAft>
-              <a:defRPr sz="1300" b="1">
-                <a:solidFill>
-                  <a:srgbClr val="142B46"/>
-                </a:solidFill>
-                <a:latin typeface="Noto Sans CJK SC"/>
-              </a:defRPr>
-            </a:pPr>
-            <a:r>
-              <a:t>全局目标方位误差</a:t>
+              <a:t>下一步假设：既然难例伴随更强的近期旋转，就检验视觉历史能否帮助方向预测。</a:t>
             </a:r>
           </a:p>
         </p:txBody>
@@ -4985,680 +4977,8 @@
         </p:nvSpPr>
         <p:spPr>
           <a:xfrm>
-            <a:off x="6345936" y="4187952"/>
-            <a:ext cx="2286000" cy="237744"/>
-          </a:xfrm>
-          <a:prstGeom prst="rect">
-            <a:avLst/>
-          </a:prstGeom>
-          <a:noFill/>
-          <a:effectLst/>
-        </p:spPr>
-        <p:txBody>
-          <a:bodyPr wrap="none" lIns="0" rIns="0" tIns="0" bIns="0">
-            <a:spAutoFit/>
-          </a:bodyPr>
-          <a:lstStyle/>
-          <a:p>
-            <a:pPr>
-              <a:spcAft>
-                <a:spcPts val="700"/>
-              </a:spcAft>
-              <a:defRPr sz="1000" b="0">
-                <a:solidFill>
-                  <a:srgbClr val="62748A"/>
-                </a:solidFill>
-                <a:latin typeface="Noto Sans CJK SC"/>
-              </a:defRPr>
-            </a:pPr>
-            <a:r>
-              <a:t>Goal 方向也常同时出错</a:t>
-            </a:r>
-          </a:p>
-        </p:txBody>
-      </p:sp>
-      <p:sp>
-        <p:nvSpPr>
-          <p:cNvPr id="37" name="Rounded Rectangle 36"/>
-          <p:cNvSpPr/>
-          <p:nvPr/>
-        </p:nvSpPr>
-        <p:spPr>
-          <a:xfrm>
-            <a:off x="6345936" y="4668012"/>
-            <a:ext cx="1320799" cy="146304"/>
-          </a:xfrm>
-          <a:prstGeom prst="roundRect">
-            <a:avLst>
-              <a:gd name="adj" fmla="val 12000"/>
-            </a:avLst>
-          </a:prstGeom>
-          <a:solidFill>
-            <a:srgbClr val="148D91"/>
-          </a:solidFill>
-          <a:ln>
-            <a:noFill/>
-          </a:ln>
-          <a:effectLst/>
-        </p:spPr>
-        <p:style>
-          <a:lnRef idx="1">
-            <a:schemeClr val="accent1"/>
-          </a:lnRef>
-          <a:fillRef idx="3">
-            <a:schemeClr val="accent1"/>
-          </a:fillRef>
-          <a:effectRef idx="0">
-            <a:schemeClr val="accent1"/>
-          </a:effectRef>
-          <a:fontRef idx="minor">
-            <a:schemeClr val="lt1"/>
-          </a:fontRef>
-        </p:style>
-        <p:txBody>
-          <a:bodyPr rtlCol="0" anchor="ctr"/>
-          <a:lstStyle/>
-          <a:p>
-            <a:pPr algn="ctr"/>
-          </a:p>
-        </p:txBody>
-      </p:sp>
-      <p:sp>
-        <p:nvSpPr>
-          <p:cNvPr id="38" name="TextBox 37"/>
-          <p:cNvSpPr txBox="1"/>
-          <p:nvPr/>
-        </p:nvSpPr>
-        <p:spPr>
-          <a:xfrm>
-            <a:off x="7863840" y="4576572"/>
-            <a:ext cx="813816" cy="292608"/>
-          </a:xfrm>
-          <a:prstGeom prst="rect">
-            <a:avLst/>
-          </a:prstGeom>
-          <a:noFill/>
-          <a:effectLst/>
-        </p:spPr>
-        <p:txBody>
-          <a:bodyPr wrap="none" lIns="0" rIns="0" tIns="0" bIns="0">
-            <a:spAutoFit/>
-          </a:bodyPr>
-          <a:lstStyle/>
-          <a:p>
-            <a:pPr>
-              <a:spcAft>
-                <a:spcPts val="700"/>
-              </a:spcAft>
-              <a:defRPr sz="1400" b="1">
-                <a:solidFill>
-                  <a:srgbClr val="148D91"/>
-                </a:solidFill>
-                <a:latin typeface="Noto Sans CJK SC"/>
-              </a:defRPr>
-            </a:pPr>
-            <a:r>
-              <a:t>50.4°</a:t>
-            </a:r>
-          </a:p>
-        </p:txBody>
-      </p:sp>
-      <p:sp>
-        <p:nvSpPr>
-          <p:cNvPr id="39" name="Rounded Rectangle 38"/>
-          <p:cNvSpPr/>
-          <p:nvPr/>
-        </p:nvSpPr>
-        <p:spPr>
-          <a:xfrm>
-            <a:off x="6345936" y="5052060"/>
-            <a:ext cx="399058" cy="146304"/>
-          </a:xfrm>
-          <a:prstGeom prst="roundRect">
-            <a:avLst>
-              <a:gd name="adj" fmla="val 12000"/>
-            </a:avLst>
-          </a:prstGeom>
-          <a:solidFill>
-            <a:srgbClr val="9CB5D8"/>
-          </a:solidFill>
-          <a:ln>
-            <a:noFill/>
-          </a:ln>
-          <a:effectLst/>
-        </p:spPr>
-        <p:style>
-          <a:lnRef idx="1">
-            <a:schemeClr val="accent1"/>
-          </a:lnRef>
-          <a:fillRef idx="3">
-            <a:schemeClr val="accent1"/>
-          </a:fillRef>
-          <a:effectRef idx="0">
-            <a:schemeClr val="accent1"/>
-          </a:effectRef>
-          <a:fontRef idx="minor">
-            <a:schemeClr val="lt1"/>
-          </a:fontRef>
-        </p:style>
-        <p:txBody>
-          <a:bodyPr rtlCol="0" anchor="ctr"/>
-          <a:lstStyle/>
-          <a:p>
-            <a:pPr algn="ctr"/>
-          </a:p>
-        </p:txBody>
-      </p:sp>
-      <p:sp>
-        <p:nvSpPr>
-          <p:cNvPr id="40" name="TextBox 39"/>
-          <p:cNvSpPr txBox="1"/>
-          <p:nvPr/>
-        </p:nvSpPr>
-        <p:spPr>
-          <a:xfrm>
-            <a:off x="7863840" y="4960620"/>
-            <a:ext cx="813816" cy="292608"/>
-          </a:xfrm>
-          <a:prstGeom prst="rect">
-            <a:avLst/>
-          </a:prstGeom>
-          <a:noFill/>
-          <a:effectLst/>
-        </p:spPr>
-        <p:txBody>
-          <a:bodyPr wrap="none" lIns="0" rIns="0" tIns="0" bIns="0">
-            <a:spAutoFit/>
-          </a:bodyPr>
-          <a:lstStyle/>
-          <a:p>
-            <a:pPr>
-              <a:spcAft>
-                <a:spcPts val="700"/>
-              </a:spcAft>
-              <a:defRPr sz="1400" b="1">
-                <a:solidFill>
-                  <a:srgbClr val="62748A"/>
-                </a:solidFill>
-                <a:latin typeface="Noto Sans CJK SC"/>
-              </a:defRPr>
-            </a:pPr>
-            <a:r>
-              <a:t>15.2°</a:t>
-            </a:r>
-          </a:p>
-        </p:txBody>
-      </p:sp>
-      <p:sp>
-        <p:nvSpPr>
-          <p:cNvPr id="41" name="Rounded Rectangle 40"/>
-          <p:cNvSpPr/>
-          <p:nvPr/>
-        </p:nvSpPr>
-        <p:spPr>
-          <a:xfrm>
-            <a:off x="8970264" y="3675887"/>
-            <a:ext cx="2542032" cy="1728216"/>
-          </a:xfrm>
-          <a:prstGeom prst="roundRect">
-            <a:avLst>
-              <a:gd name="adj" fmla="val 12000"/>
-            </a:avLst>
-          </a:prstGeom>
-          <a:solidFill>
-            <a:srgbClr val="F0F4F8"/>
-          </a:solidFill>
-          <a:ln>
-            <a:noFill/>
-          </a:ln>
-          <a:effectLst/>
-        </p:spPr>
-        <p:style>
-          <a:lnRef idx="1">
-            <a:schemeClr val="accent1"/>
-          </a:lnRef>
-          <a:fillRef idx="3">
-            <a:schemeClr val="accent1"/>
-          </a:fillRef>
-          <a:effectRef idx="0">
-            <a:schemeClr val="accent1"/>
-          </a:effectRef>
-          <a:fontRef idx="minor">
-            <a:schemeClr val="lt1"/>
-          </a:fontRef>
-        </p:style>
-        <p:txBody>
-          <a:bodyPr rtlCol="0" anchor="ctr"/>
-          <a:lstStyle/>
-          <a:p>
-            <a:pPr algn="ctr"/>
-          </a:p>
-        </p:txBody>
-      </p:sp>
-      <p:sp>
-        <p:nvSpPr>
-          <p:cNvPr id="42" name="TextBox 41"/>
-          <p:cNvSpPr txBox="1"/>
-          <p:nvPr/>
-        </p:nvSpPr>
-        <p:spPr>
-          <a:xfrm>
-            <a:off x="9107424" y="3831336"/>
-            <a:ext cx="2286000" cy="283464"/>
-          </a:xfrm>
-          <a:prstGeom prst="rect">
-            <a:avLst/>
-          </a:prstGeom>
-          <a:noFill/>
-          <a:effectLst/>
-        </p:spPr>
-        <p:txBody>
-          <a:bodyPr wrap="none" lIns="0" rIns="0" tIns="0" bIns="0">
-            <a:spAutoFit/>
-          </a:bodyPr>
-          <a:lstStyle/>
-          <a:p>
-            <a:pPr>
-              <a:spcAft>
-                <a:spcPts val="700"/>
-              </a:spcAft>
-              <a:defRPr sz="1300" b="1">
-                <a:solidFill>
-                  <a:srgbClr val="142B46"/>
-                </a:solidFill>
-                <a:latin typeface="Noto Sans CJK SC"/>
-              </a:defRPr>
-            </a:pPr>
-            <a:r>
-              <a:t>WP 方向集中度 κ</a:t>
-            </a:r>
-          </a:p>
-        </p:txBody>
-      </p:sp>
-      <p:sp>
-        <p:nvSpPr>
-          <p:cNvPr id="43" name="TextBox 42"/>
-          <p:cNvSpPr txBox="1"/>
-          <p:nvPr/>
-        </p:nvSpPr>
-        <p:spPr>
-          <a:xfrm>
-            <a:off x="9107424" y="4187952"/>
-            <a:ext cx="2286000" cy="237744"/>
-          </a:xfrm>
-          <a:prstGeom prst="rect">
-            <a:avLst/>
-          </a:prstGeom>
-          <a:noFill/>
-          <a:effectLst/>
-        </p:spPr>
-        <p:txBody>
-          <a:bodyPr wrap="none" lIns="0" rIns="0" tIns="0" bIns="0">
-            <a:spAutoFit/>
-          </a:bodyPr>
-          <a:lstStyle/>
-          <a:p>
-            <a:pPr>
-              <a:spcAft>
-                <a:spcPts val="700"/>
-              </a:spcAft>
-              <a:defRPr sz="1000" b="0">
-                <a:solidFill>
-                  <a:srgbClr val="62748A"/>
-                </a:solidFill>
-                <a:latin typeface="Noto Sans CJK SC"/>
-              </a:defRPr>
-            </a:pPr>
-            <a:r>
-              <a:t>Head 输出，用于融合加权</a:t>
-            </a:r>
-          </a:p>
-        </p:txBody>
-      </p:sp>
-      <p:sp>
-        <p:nvSpPr>
-          <p:cNvPr id="44" name="Rounded Rectangle 43"/>
-          <p:cNvSpPr/>
-          <p:nvPr/>
-        </p:nvSpPr>
-        <p:spPr>
-          <a:xfrm>
-            <a:off x="9107424" y="4668012"/>
-            <a:ext cx="328627" cy="146304"/>
-          </a:xfrm>
-          <a:prstGeom prst="roundRect">
-            <a:avLst>
-              <a:gd name="adj" fmla="val 12000"/>
-            </a:avLst>
-          </a:prstGeom>
-          <a:solidFill>
-            <a:srgbClr val="148D91"/>
-          </a:solidFill>
-          <a:ln>
-            <a:noFill/>
-          </a:ln>
-          <a:effectLst/>
-        </p:spPr>
-        <p:style>
-          <a:lnRef idx="1">
-            <a:schemeClr val="accent1"/>
-          </a:lnRef>
-          <a:fillRef idx="3">
-            <a:schemeClr val="accent1"/>
-          </a:fillRef>
-          <a:effectRef idx="0">
-            <a:schemeClr val="accent1"/>
-          </a:effectRef>
-          <a:fontRef idx="minor">
-            <a:schemeClr val="lt1"/>
-          </a:fontRef>
-        </p:style>
-        <p:txBody>
-          <a:bodyPr rtlCol="0" anchor="ctr"/>
-          <a:lstStyle/>
-          <a:p>
-            <a:pPr algn="ctr"/>
-          </a:p>
-        </p:txBody>
-      </p:sp>
-      <p:sp>
-        <p:nvSpPr>
-          <p:cNvPr id="45" name="TextBox 44"/>
-          <p:cNvSpPr txBox="1"/>
-          <p:nvPr/>
-        </p:nvSpPr>
-        <p:spPr>
-          <a:xfrm>
-            <a:off x="10625328" y="4576572"/>
-            <a:ext cx="813816" cy="292608"/>
-          </a:xfrm>
-          <a:prstGeom prst="rect">
-            <a:avLst/>
-          </a:prstGeom>
-          <a:noFill/>
-          <a:effectLst/>
-        </p:spPr>
-        <p:txBody>
-          <a:bodyPr wrap="none" lIns="0" rIns="0" tIns="0" bIns="0">
-            <a:spAutoFit/>
-          </a:bodyPr>
-          <a:lstStyle/>
-          <a:p>
-            <a:pPr>
-              <a:spcAft>
-                <a:spcPts val="700"/>
-              </a:spcAft>
-              <a:defRPr sz="1400" b="1">
-                <a:solidFill>
-                  <a:srgbClr val="148D91"/>
-                </a:solidFill>
-                <a:latin typeface="Noto Sans CJK SC"/>
-              </a:defRPr>
-            </a:pPr>
-            <a:r>
-              <a:t>8.9</a:t>
-            </a:r>
-          </a:p>
-        </p:txBody>
-      </p:sp>
-      <p:sp>
-        <p:nvSpPr>
-          <p:cNvPr id="46" name="Rounded Rectangle 45"/>
-          <p:cNvSpPr/>
-          <p:nvPr/>
-        </p:nvSpPr>
-        <p:spPr>
-          <a:xfrm>
-            <a:off x="9107424" y="5052060"/>
-            <a:ext cx="1320799" cy="146304"/>
-          </a:xfrm>
-          <a:prstGeom prst="roundRect">
-            <a:avLst>
-              <a:gd name="adj" fmla="val 12000"/>
-            </a:avLst>
-          </a:prstGeom>
-          <a:solidFill>
-            <a:srgbClr val="9CB5D8"/>
-          </a:solidFill>
-          <a:ln>
-            <a:noFill/>
-          </a:ln>
-          <a:effectLst/>
-        </p:spPr>
-        <p:style>
-          <a:lnRef idx="1">
-            <a:schemeClr val="accent1"/>
-          </a:lnRef>
-          <a:fillRef idx="3">
-            <a:schemeClr val="accent1"/>
-          </a:fillRef>
-          <a:effectRef idx="0">
-            <a:schemeClr val="accent1"/>
-          </a:effectRef>
-          <a:fontRef idx="minor">
-            <a:schemeClr val="lt1"/>
-          </a:fontRef>
-        </p:style>
-        <p:txBody>
-          <a:bodyPr rtlCol="0" anchor="ctr"/>
-          <a:lstStyle/>
-          <a:p>
-            <a:pPr algn="ctr"/>
-          </a:p>
-        </p:txBody>
-      </p:sp>
-      <p:sp>
-        <p:nvSpPr>
-          <p:cNvPr id="47" name="TextBox 46"/>
-          <p:cNvSpPr txBox="1"/>
-          <p:nvPr/>
-        </p:nvSpPr>
-        <p:spPr>
-          <a:xfrm>
-            <a:off x="10625328" y="4960620"/>
-            <a:ext cx="813816" cy="292608"/>
-          </a:xfrm>
-          <a:prstGeom prst="rect">
-            <a:avLst/>
-          </a:prstGeom>
-          <a:noFill/>
-          <a:effectLst/>
-        </p:spPr>
-        <p:txBody>
-          <a:bodyPr wrap="none" lIns="0" rIns="0" tIns="0" bIns="0">
-            <a:spAutoFit/>
-          </a:bodyPr>
-          <a:lstStyle/>
-          <a:p>
-            <a:pPr>
-              <a:spcAft>
-                <a:spcPts val="700"/>
-              </a:spcAft>
-              <a:defRPr sz="1400" b="1">
-                <a:solidFill>
-                  <a:srgbClr val="62748A"/>
-                </a:solidFill>
-                <a:latin typeface="Noto Sans CJK SC"/>
-              </a:defRPr>
-            </a:pPr>
-            <a:r>
-              <a:t>35.8</a:t>
-            </a:r>
-          </a:p>
-        </p:txBody>
-      </p:sp>
-      <p:sp>
-        <p:nvSpPr>
-          <p:cNvPr id="48" name="TextBox 47"/>
-          <p:cNvSpPr txBox="1"/>
-          <p:nvPr/>
-        </p:nvSpPr>
-        <p:spPr>
-          <a:xfrm>
-            <a:off x="685800" y="5541264"/>
-            <a:ext cx="10972800" cy="246888"/>
-          </a:xfrm>
-          <a:prstGeom prst="rect">
-            <a:avLst/>
-          </a:prstGeom>
-          <a:noFill/>
-          <a:effectLst/>
-        </p:spPr>
-        <p:txBody>
-          <a:bodyPr wrap="none" lIns="0" rIns="0" tIns="0" bIns="0">
-            <a:spAutoFit/>
-          </a:bodyPr>
-          <a:lstStyle/>
-          <a:p>
-            <a:pPr>
-              <a:spcAft>
-                <a:spcPts val="700"/>
-              </a:spcAft>
-              <a:defRPr sz="1100" b="0">
-                <a:solidFill>
-                  <a:srgbClr val="62748A"/>
-                </a:solidFill>
-                <a:latin typeface="Noto Sans CJK SC"/>
-              </a:defRPr>
-            </a:pPr>
-            <a:r>
-              <a:t>κ 更低表示预测分布更分散；这些组间差异是相关性证据，不能直接证明因果。</a:t>
-            </a:r>
-          </a:p>
-        </p:txBody>
-      </p:sp>
-      <p:sp>
-        <p:nvSpPr>
-          <p:cNvPr id="49" name="Rounded Rectangle 48"/>
-          <p:cNvSpPr/>
-          <p:nvPr/>
-        </p:nvSpPr>
-        <p:spPr>
-          <a:xfrm>
-            <a:off x="685800" y="5952744"/>
-            <a:ext cx="10826496" cy="448056"/>
-          </a:xfrm>
-          <a:prstGeom prst="roundRect">
-            <a:avLst>
-              <a:gd name="adj" fmla="val 12000"/>
-            </a:avLst>
-          </a:prstGeom>
-          <a:solidFill>
-            <a:srgbClr val="E8F4F2"/>
-          </a:solidFill>
-          <a:ln>
-            <a:noFill/>
-          </a:ln>
-          <a:effectLst/>
-        </p:spPr>
-        <p:style>
-          <a:lnRef idx="1">
-            <a:schemeClr val="accent1"/>
-          </a:lnRef>
-          <a:fillRef idx="3">
-            <a:schemeClr val="accent1"/>
-          </a:fillRef>
-          <a:effectRef idx="0">
-            <a:schemeClr val="accent1"/>
-          </a:effectRef>
-          <a:fontRef idx="minor">
-            <a:schemeClr val="lt1"/>
-          </a:fontRef>
-        </p:style>
-        <p:txBody>
-          <a:bodyPr rtlCol="0" anchor="ctr"/>
-          <a:lstStyle/>
-          <a:p>
-            <a:pPr algn="ctr"/>
-          </a:p>
-        </p:txBody>
-      </p:sp>
-      <p:sp>
-        <p:nvSpPr>
-          <p:cNvPr id="50" name="TextBox 49"/>
-          <p:cNvSpPr txBox="1"/>
-          <p:nvPr/>
-        </p:nvSpPr>
-        <p:spPr>
-          <a:xfrm>
-            <a:off x="859536" y="6035040"/>
-            <a:ext cx="10424160" cy="283464"/>
-          </a:xfrm>
-          <a:prstGeom prst="rect">
-            <a:avLst/>
-          </a:prstGeom>
-          <a:noFill/>
-          <a:effectLst/>
-        </p:spPr>
-        <p:txBody>
-          <a:bodyPr wrap="none" lIns="0" rIns="0" tIns="0" bIns="0">
-            <a:spAutoFit/>
-          </a:bodyPr>
-          <a:lstStyle/>
-          <a:p>
-            <a:pPr>
-              <a:spcAft>
-                <a:spcPts val="700"/>
-              </a:spcAft>
-              <a:defRPr sz="1500" b="1">
-                <a:solidFill>
-                  <a:srgbClr val="148D91"/>
-                </a:solidFill>
-                <a:latin typeface="Noto Sans CJK SC"/>
-              </a:defRPr>
-            </a:pPr>
-            <a:r>
-              <a:t>启示：转弯与近期旋转运动值得关注，为引入视觉历史提供实验动机。</a:t>
-            </a:r>
-          </a:p>
-        </p:txBody>
-      </p:sp>
-      <p:cxnSp>
-        <p:nvCxnSpPr>
-          <p:cNvPr id="51" name="Connector 50"/>
-          <p:cNvCxnSpPr/>
-          <p:nvPr/>
-        </p:nvCxnSpPr>
-        <p:spPr>
-          <a:xfrm>
-            <a:off x="685800" y="6519672"/>
-            <a:ext cx="10817352" cy="0"/>
-          </a:xfrm>
-          <a:prstGeom prst="line">
-            <a:avLst/>
-          </a:prstGeom>
-          <a:ln w="10160">
-            <a:solidFill>
-              <a:srgbClr val="DCE5EF"/>
-            </a:solidFill>
-          </a:ln>
-          <a:effectLst/>
-        </p:spPr>
-        <p:style>
-          <a:lnRef idx="2">
-            <a:schemeClr val="accent1"/>
-          </a:lnRef>
-          <a:fillRef idx="0">
-            <a:schemeClr val="accent1"/>
-          </a:fillRef>
-          <a:effectRef idx="0">
-            <a:schemeClr val="accent1"/>
-          </a:effectRef>
-          <a:fontRef idx="minor">
-            <a:schemeClr val="tx1"/>
-          </a:fontRef>
-        </p:style>
-      </p:cxnSp>
-      <p:sp>
-        <p:nvSpPr>
-          <p:cNvPr id="52" name="TextBox 51"/>
-          <p:cNvSpPr txBox="1"/>
-          <p:nvPr/>
-        </p:nvSpPr>
-        <p:spPr>
-          <a:xfrm>
-            <a:off x="685800" y="6601968"/>
-            <a:ext cx="9875520" cy="182880"/>
+            <a:off x="685800" y="6684264"/>
+            <a:ext cx="10058400" cy="146304"/>
           </a:xfrm>
           <a:prstGeom prst="rect">
             <a:avLst/>
@@ -5684,21 +5004,21 @@
               </a:defRPr>
             </a:pPr>
             <a:r>
-              <a:t>来源：wp_hard120/summary.txt、enrichment_H_vs_control.csv；各指标使用独立刻度。</a:t>
-            </a:r>
-          </a:p>
-        </p:txBody>
-      </p:sp>
-      <p:sp>
-        <p:nvSpPr>
-          <p:cNvPr id="53" name="TextBox 52"/>
+              <a:t>来源：wp_hard120/summary.txt、enrichment_H_vs_control.csv（C_match）；两图按各自指标独立定标。</a:t>
+            </a:r>
+          </a:p>
+        </p:txBody>
+      </p:sp>
+      <p:sp>
+        <p:nvSpPr>
+          <p:cNvPr id="37" name="TextBox 36"/>
           <p:cNvSpPr txBox="1"/>
           <p:nvPr/>
         </p:nvSpPr>
         <p:spPr>
           <a:xfrm>
-            <a:off x="10497312" y="6601968"/>
-            <a:ext cx="1005840" cy="182880"/>
+            <a:off x="10378440" y="6684264"/>
+            <a:ext cx="1133856" cy="146304"/>
           </a:xfrm>
           <a:prstGeom prst="rect">
             <a:avLst/>
@@ -5724,7 +5044,7 @@
               </a:defRPr>
             </a:pPr>
             <a:r>
-              <a:t>难例分析 / 05</a:t>
+              <a:t>难例特征 / 05</a:t>
             </a:r>
           </a:p>
         </p:txBody>

</xml_diff>

<commit_message>
Revise Hard120 slide to focus on difficult-sample errors and characteristics
</commit_message>
<xml_diff>
--- a/presentations/slide05_hard120_analysis_cn.pptx
+++ b/presentations/slide05_hard120_analysis_cn.pptx
@@ -502,37 +502,37 @@
           <a:lstStyle/>
           <a:p>
             <a:r>
-              <a:t>第5页重写：承接收益归因页，问题改为转弯比例相近时困难样本还有哪些运动特征，不再用“错误出现在哪里”的标题承载多个无关特征。</a:t>
-            </a:r>
-          </a:p>
-          <a:p>
-            <a:r>
-              <a:t>来源main c1b3750，train/logs/revalidation/wp_hard120/summary.txt、enrichment_H_vs_control.csv（control=C_match）、train/analyze_wp_hard120.py。</a:t>
-            </a:r>
-          </a:p>
-          <a:p>
-            <a:r>
-              <a:t>Hard为预测WP相对真实8步endpoint方位误差&gt;=45deg，n=120，属于locked1000帧的12%。strict turn=GT endpoint abs(lateral)&gt;=.30m OR abs(yawchange)&gt;=45deg，Hard中占93.333%。C_match从非hard池抽样，匹配strict turn比例93.333%；它并非全部普通帧，也不是所有其他混杂因素均已控制。</a:t>
-            </a:r>
-          </a:p>
-          <a:p>
-            <a:r>
-              <a:t>未来累计绝对转角path_winding_8 med_H108.48499999999994 / med_C69.43119048174236deg（页内108.5/69.4）；历史平均步间转角past_yaw_rate med_H14.101111111111116 / med_C7.349444444444433deg（页内14.10/7.35）。后者是过去最多3采样步绝对yaw变化均值，不是deg/s角速度。</a:t>
-            </a:r>
-          </a:p>
-          <a:p>
-            <a:r>
-              <a:t>比较为中位数，两指标分别从零按120deg和16deg线性刻度画柱。只描述相关特征，不作因果断言。由此提出“视觉历史是否帮助”的可检验假设，下一页P2才给实验回答。</a:t>
-            </a:r>
-          </a:p>
-          <a:p>
-            <a:r>
-              <a:t>Goal方位误差与κ比较从主页面移出，以聚焦引出历史实验的证据；18.3%按此前用户要求不显示。</a:t>
-            </a:r>
-          </a:p>
-          <a:p>
-            <a:r>
-              <a:t>资料限制：CSV n_C与研究设计/当前代码不一致（62770 vs设计120），无法无原始NPZ复算；不报告对照数，采用与summary.txt一致的中位数，不据此计算新显著性。统计来自上传汇总，非本次重跑。</a:t>
+              <a:t>第5页按用户现有版式修订：保留标题逻辑和两个运动特征卡片，移除对照组卡片、数值与柱条。先难例表现，再运动特点；不更新合并稿。</a:t>
+            </a:r>
+          </a:p>
+          <a:p>
+            <a:r>
+              <a:t>来源train/logs/revalidation/wp_hard120/summary.txt与enrichment_H_vs_control.csv；统计来自用户上传汇总，未重跑。</a:t>
+            </a:r>
+          </a:p>
+          <a:p>
+            <a:r>
+              <a:t>Hard为预测WP方向相对真实第8步endpoint方向角误差&gt;=45deg，120/locked1000=12%。误差中位70.07deg（summary），是按误差筛选后的条件统计，不作为独立发现或普遍错误率。</a:t>
+            </a:r>
+          </a:p>
+          <a:p>
+            <a:r>
+              <a:t>未来8步累计绝对转角中位108.48499999999994（显示108.5），历史平均步间转角中位14.101111111111116（显示14.10），过去最多3采样步的abs yaw变化均值，不是deg/s。</a:t>
+            </a:r>
+          </a:p>
+          <a:p>
+            <a:r>
+              <a:t>93.333% strictturn，GT第8步相对当前位置车体坐标横向绝对值&gt;=.30m OR当前到未来第8步yaw wrapped变化绝对值&gt;=45deg；不是模型方向误差定义的同一个45deg。定义与locked TURN_STRICT一致。</a:t>
+            </a:r>
+          </a:p>
+          <a:p>
+            <a:r>
+              <a:t>删除所有对照数值与更弯/更强比较措辞，不作组间或因果推断。特征只是提出引入历史的待检验假设；下一页P2独立比较ctx0/ctx2才检验历史是否有效。</a:t>
+            </a:r>
+          </a:p>
+          <a:p>
+            <a:r>
+              <a:t>原始CSV虽以C_match行组织，但本页只读median_H，不使用median_C或存在口径疑问的n_C。18.3%、Goal误差和κ统计仍按此前偏好不显示。</a:t>
             </a:r>
           </a:p>
           <a:p/>
@@ -3670,7 +3670,7 @@
               </a:defRPr>
             </a:pPr>
             <a:r>
-              <a:t>P1b / 从转弯集中现象，到运动特征对比</a:t>
+              <a:t>P1b / Hard120 失败样本分析</a:t>
             </a:r>
           </a:p>
         </p:txBody>
@@ -3710,7 +3710,7 @@
               </a:defRPr>
             </a:pPr>
             <a:r>
-              <a:t>转弯比例相近时，难例还有什么特点？</a:t>
+              <a:t>分析难例特点，寻找提升方法</a:t>
             </a:r>
           </a:p>
         </p:txBody>
@@ -3750,7 +3750,7 @@
               </a:defRPr>
             </a:pPr>
             <a:r>
-              <a:t>承接上一页：严重错误集中在转弯场景；这里进一步比较困难帧与非困难帧的运动特征。</a:t>
+              <a:t>先看严重错误有多大，再看这些难例的运动特点；本页只展示 Hard120 内部统计。</a:t>
             </a:r>
           </a:p>
         </p:txBody>
@@ -3764,7 +3764,7 @@
         <p:spPr>
           <a:xfrm>
             <a:off x="685800" y="2249424"/>
-            <a:ext cx="5303520" cy="685800"/>
+            <a:ext cx="5303520" cy="786384"/>
           </a:xfrm>
           <a:prstGeom prst="roundRect">
             <a:avLst>
@@ -3803,94 +3803,14 @@
       </p:sp>
       <p:sp>
         <p:nvSpPr>
-          <p:cNvPr id="8" name="TextBox 7"/>
-          <p:cNvSpPr txBox="1"/>
-          <p:nvPr/>
-        </p:nvSpPr>
-        <p:spPr>
-          <a:xfrm>
-            <a:off x="841248" y="2350008"/>
-            <a:ext cx="4983480" cy="265176"/>
-          </a:xfrm>
-          <a:prstGeom prst="rect">
-            <a:avLst/>
-          </a:prstGeom>
-          <a:noFill/>
-          <a:effectLst/>
-        </p:spPr>
-        <p:txBody>
-          <a:bodyPr wrap="none" lIns="0" rIns="0" tIns="0" bIns="0">
-            <a:spAutoFit/>
-          </a:bodyPr>
-          <a:lstStyle/>
-          <a:p>
-            <a:pPr>
-              <a:spcAft>
-                <a:spcPts val="700"/>
-              </a:spcAft>
-              <a:defRPr sz="1400" b="1">
-                <a:solidFill>
-                  <a:srgbClr val="142B46"/>
-                </a:solidFill>
-                <a:latin typeface="Noto Sans CJK SC"/>
-              </a:defRPr>
-            </a:pPr>
-            <a:r>
-              <a:t>困难组：120 帧</a:t>
-            </a:r>
-          </a:p>
-        </p:txBody>
-      </p:sp>
-      <p:sp>
-        <p:nvSpPr>
-          <p:cNvPr id="9" name="TextBox 8"/>
-          <p:cNvSpPr txBox="1"/>
-          <p:nvPr/>
-        </p:nvSpPr>
-        <p:spPr>
-          <a:xfrm>
-            <a:off x="841248" y="2734056"/>
-            <a:ext cx="4983480" cy="210312"/>
-          </a:xfrm>
-          <a:prstGeom prst="rect">
-            <a:avLst/>
-          </a:prstGeom>
-          <a:noFill/>
-          <a:effectLst/>
-        </p:spPr>
-        <p:txBody>
-          <a:bodyPr wrap="none" lIns="0" rIns="0" tIns="0" bIns="0">
-            <a:spAutoFit/>
-          </a:bodyPr>
-          <a:lstStyle/>
-          <a:p>
-            <a:pPr>
-              <a:spcAft>
-                <a:spcPts val="700"/>
-              </a:spcAft>
-              <a:defRPr sz="1000" b="0">
-                <a:solidFill>
-                  <a:srgbClr val="62748A"/>
-                </a:solidFill>
-                <a:latin typeface="Noto Sans CJK SC"/>
-              </a:defRPr>
-            </a:pPr>
-            <a:r>
-              <a:t>WP 方向误差 ≥45°；其中严格转弯占 93.3%。</a:t>
-            </a:r>
-          </a:p>
-        </p:txBody>
-      </p:sp>
-      <p:sp>
-        <p:nvSpPr>
-          <p:cNvPr id="10" name="Rounded Rectangle 9"/>
+          <p:cNvPr id="8" name="Rounded Rectangle 7"/>
           <p:cNvSpPr/>
           <p:nvPr/>
         </p:nvSpPr>
         <p:spPr>
           <a:xfrm>
             <a:off x="6208776" y="2249424"/>
-            <a:ext cx="5303520" cy="685800"/>
+            <a:ext cx="5303520" cy="786384"/>
           </a:xfrm>
           <a:prstGeom prst="roundRect">
             <a:avLst>
@@ -3929,14 +3849,14 @@
       </p:sp>
       <p:sp>
         <p:nvSpPr>
-          <p:cNvPr id="11" name="TextBox 10"/>
+          <p:cNvPr id="9" name="TextBox 8"/>
           <p:cNvSpPr txBox="1"/>
           <p:nvPr/>
         </p:nvSpPr>
         <p:spPr>
           <a:xfrm>
-            <a:off x="6364224" y="2350008"/>
-            <a:ext cx="4983480" cy="265176"/>
+            <a:off x="859536" y="2359152"/>
+            <a:ext cx="4956048" cy="320040"/>
           </a:xfrm>
           <a:prstGeom prst="rect">
             <a:avLst/>
@@ -3954,29 +3874,29 @@
               <a:spcAft>
                 <a:spcPts val="700"/>
               </a:spcAft>
-              <a:defRPr sz="1400" b="1">
+              <a:defRPr sz="1800" b="1">
                 <a:solidFill>
-                  <a:srgbClr val="142B46"/>
+                  <a:srgbClr val="148D91"/>
                 </a:solidFill>
                 <a:latin typeface="Noto Sans CJK SC"/>
               </a:defRPr>
             </a:pPr>
             <a:r>
-              <a:t>对照组：从非困难帧中选取</a:t>
-            </a:r>
-          </a:p>
-        </p:txBody>
-      </p:sp>
-      <p:sp>
-        <p:nvSpPr>
-          <p:cNvPr id="12" name="TextBox 11"/>
+              <a:t>120 帧｜占 locked 1000 帧的 12%</a:t>
+            </a:r>
+          </a:p>
+        </p:txBody>
+      </p:sp>
+      <p:sp>
+        <p:nvSpPr>
+          <p:cNvPr id="10" name="TextBox 9"/>
           <p:cNvSpPr txBox="1"/>
           <p:nvPr/>
         </p:nvSpPr>
         <p:spPr>
           <a:xfrm>
-            <a:off x="6364224" y="2734056"/>
-            <a:ext cx="4983480" cy="210312"/>
+            <a:off x="859536" y="2798064"/>
+            <a:ext cx="4956048" cy="219456"/>
           </a:xfrm>
           <a:prstGeom prst="rect">
             <a:avLst/>
@@ -3994,7 +3914,7 @@
               <a:spcAft>
                 <a:spcPts val="700"/>
               </a:spcAft>
-              <a:defRPr sz="1000" b="0">
+              <a:defRPr sz="1100" b="0">
                 <a:solidFill>
                   <a:srgbClr val="62748A"/>
                 </a:solidFill>
@@ -4002,7 +3922,87 @@
               </a:defRPr>
             </a:pPr>
             <a:r>
-              <a:t>匹配转弯占比为 93.3%，减少弯道与直道差异的影响。</a:t>
+              <a:t>难例定义：航点（WP）方向误差 ≥45°。</a:t>
+            </a:r>
+          </a:p>
+        </p:txBody>
+      </p:sp>
+      <p:sp>
+        <p:nvSpPr>
+          <p:cNvPr id="11" name="TextBox 10"/>
+          <p:cNvSpPr txBox="1"/>
+          <p:nvPr/>
+        </p:nvSpPr>
+        <p:spPr>
+          <a:xfrm>
+            <a:off x="6382512" y="2359152"/>
+            <a:ext cx="4956048" cy="320040"/>
+          </a:xfrm>
+          <a:prstGeom prst="rect">
+            <a:avLst/>
+          </a:prstGeom>
+          <a:noFill/>
+          <a:effectLst/>
+        </p:spPr>
+        <p:txBody>
+          <a:bodyPr wrap="none" lIns="0" rIns="0" tIns="0" bIns="0">
+            <a:spAutoFit/>
+          </a:bodyPr>
+          <a:lstStyle/>
+          <a:p>
+            <a:pPr>
+              <a:spcAft>
+                <a:spcPts val="700"/>
+              </a:spcAft>
+              <a:defRPr sz="1800" b="1">
+                <a:solidFill>
+                  <a:srgbClr val="148D91"/>
+                </a:solidFill>
+                <a:latin typeface="Noto Sans CJK SC"/>
+              </a:defRPr>
+            </a:pPr>
+            <a:r>
+              <a:t>70.07°｜难例方向误差中位数</a:t>
+            </a:r>
+          </a:p>
+        </p:txBody>
+      </p:sp>
+      <p:sp>
+        <p:nvSpPr>
+          <p:cNvPr id="12" name="TextBox 11"/>
+          <p:cNvSpPr txBox="1"/>
+          <p:nvPr/>
+        </p:nvSpPr>
+        <p:spPr>
+          <a:xfrm>
+            <a:off x="6382512" y="2798064"/>
+            <a:ext cx="4956048" cy="219456"/>
+          </a:xfrm>
+          <a:prstGeom prst="rect">
+            <a:avLst/>
+          </a:prstGeom>
+          <a:noFill/>
+          <a:effectLst/>
+        </p:spPr>
+        <p:txBody>
+          <a:bodyPr wrap="none" lIns="0" rIns="0" tIns="0" bIns="0">
+            <a:spAutoFit/>
+          </a:bodyPr>
+          <a:lstStyle/>
+          <a:p>
+            <a:pPr>
+              <a:spcAft>
+                <a:spcPts val="700"/>
+              </a:spcAft>
+              <a:defRPr sz="1050" b="0">
+                <a:solidFill>
+                  <a:srgbClr val="62748A"/>
+                </a:solidFill>
+                <a:latin typeface="Noto Sans CJK SC"/>
+              </a:defRPr>
+            </a:pPr>
+            <a:r>
+              <a:t>误差：预测 WP 与真实第 8 步终点方向的夹角。</a:t>
             </a:r>
           </a:p>
         </p:txBody>
@@ -4015,8 +4015,8 @@
         </p:nvSpPr>
         <p:spPr>
           <a:xfrm>
-            <a:off x="685800" y="3310128"/>
-            <a:ext cx="5303520" cy="2276856"/>
+            <a:off x="685800" y="3337560"/>
+            <a:ext cx="5303520" cy="2194560"/>
           </a:xfrm>
           <a:prstGeom prst="roundRect">
             <a:avLst>
@@ -4061,7 +4061,7 @@
         </p:nvSpPr>
         <p:spPr>
           <a:xfrm>
-            <a:off x="850392" y="3456432"/>
+            <a:off x="850392" y="3502152"/>
             <a:ext cx="4937760" cy="329184"/>
           </a:xfrm>
           <a:prstGeom prst="rect">
@@ -4080,7 +4080,7 @@
               <a:spcAft>
                 <a:spcPts val="700"/>
               </a:spcAft>
-              <a:defRPr sz="2000" b="1">
+              <a:defRPr sz="1900" b="1">
                 <a:solidFill>
                   <a:srgbClr val="148D91"/>
                 </a:solidFill>
@@ -4088,7 +4088,7 @@
               </a:defRPr>
             </a:pPr>
             <a:r>
-              <a:t>① 未来路径更弯</a:t>
+              <a:t>① 未来路径存在明显转向</a:t>
             </a:r>
           </a:p>
         </p:txBody>
@@ -4101,8 +4101,8 @@
         </p:nvSpPr>
         <p:spPr>
           <a:xfrm>
-            <a:off x="850392" y="3922776"/>
-            <a:ext cx="4937760" cy="246888"/>
+            <a:off x="850392" y="4023360"/>
+            <a:ext cx="4937760" cy="256032"/>
           </a:xfrm>
           <a:prstGeom prst="rect">
             <a:avLst/>
@@ -4141,8 +4141,8 @@
         </p:nvSpPr>
         <p:spPr>
           <a:xfrm>
-            <a:off x="850392" y="4393692"/>
-            <a:ext cx="822960" cy="237744"/>
+            <a:off x="850392" y="4517136"/>
+            <a:ext cx="4937760" cy="502920"/>
           </a:xfrm>
           <a:prstGeom prst="rect">
             <a:avLst/>
@@ -4160,7 +4160,47 @@
               <a:spcAft>
                 <a:spcPts val="700"/>
               </a:spcAft>
-              <a:defRPr sz="1100" b="0">
+              <a:defRPr sz="3000" b="1">
+                <a:solidFill>
+                  <a:srgbClr val="148D91"/>
+                </a:solidFill>
+                <a:latin typeface="Noto Sans CJK SC"/>
+              </a:defRPr>
+            </a:pPr>
+            <a:r>
+              <a:t>108.5°</a:t>
+            </a:r>
+          </a:p>
+        </p:txBody>
+      </p:sp>
+      <p:sp>
+        <p:nvSpPr>
+          <p:cNvPr id="17" name="TextBox 16"/>
+          <p:cNvSpPr txBox="1"/>
+          <p:nvPr/>
+        </p:nvSpPr>
+        <p:spPr>
+          <a:xfrm>
+            <a:off x="850392" y="5157216"/>
+            <a:ext cx="4937760" cy="219456"/>
+          </a:xfrm>
+          <a:prstGeom prst="rect">
+            <a:avLst/>
+          </a:prstGeom>
+          <a:noFill/>
+          <a:effectLst/>
+        </p:spPr>
+        <p:txBody>
+          <a:bodyPr wrap="none" lIns="0" rIns="0" tIns="0" bIns="0">
+            <a:spAutoFit/>
+          </a:bodyPr>
+          <a:lstStyle/>
+          <a:p>
+            <a:pPr>
+              <a:spcAft>
+                <a:spcPts val="700"/>
+              </a:spcAft>
+              <a:defRPr sz="1000" b="0">
                 <a:solidFill>
                   <a:srgbClr val="62748A"/>
                 </a:solidFill>
@@ -4168,21 +4208,21 @@
               </a:defRPr>
             </a:pPr>
             <a:r>
-              <a:t>困难组</a:t>
-            </a:r>
-          </a:p>
-        </p:txBody>
-      </p:sp>
-      <p:sp>
-        <p:nvSpPr>
-          <p:cNvPr id="17" name="Rounded Rectangle 16"/>
+              <a:t>每一步转角取绝对值，再把 8 步相加。</a:t>
+            </a:r>
+          </a:p>
+        </p:txBody>
+      </p:sp>
+      <p:sp>
+        <p:nvSpPr>
+          <p:cNvPr id="18" name="Rounded Rectangle 17"/>
           <p:cNvSpPr/>
           <p:nvPr/>
         </p:nvSpPr>
         <p:spPr>
           <a:xfrm>
-            <a:off x="1755648" y="4443984"/>
-            <a:ext cx="2761030" cy="182880"/>
+            <a:off x="6208776" y="3337560"/>
+            <a:ext cx="5303520" cy="2194560"/>
           </a:xfrm>
           <a:prstGeom prst="roundRect">
             <a:avLst>
@@ -4190,7 +4230,7 @@
             </a:avLst>
           </a:prstGeom>
           <a:solidFill>
-            <a:srgbClr val="148D91"/>
+            <a:srgbClr val="F0F4F8"/>
           </a:solidFill>
           <a:ln>
             <a:noFill/>
@@ -4221,14 +4261,14 @@
       </p:sp>
       <p:sp>
         <p:nvSpPr>
-          <p:cNvPr id="18" name="TextBox 17"/>
+          <p:cNvPr id="19" name="TextBox 18"/>
           <p:cNvSpPr txBox="1"/>
           <p:nvPr/>
         </p:nvSpPr>
         <p:spPr>
           <a:xfrm>
-            <a:off x="4946904" y="4343400"/>
-            <a:ext cx="896112" cy="301752"/>
+            <a:off x="6373368" y="3502152"/>
+            <a:ext cx="4937760" cy="329184"/>
           </a:xfrm>
           <a:prstGeom prst="rect">
             <a:avLst/>
@@ -4246,7 +4286,7 @@
               <a:spcAft>
                 <a:spcPts val="700"/>
               </a:spcAft>
-              <a:defRPr sz="1700" b="1">
+              <a:defRPr sz="1900" b="1">
                 <a:solidFill>
                   <a:srgbClr val="148D91"/>
                 </a:solidFill>
@@ -4254,21 +4294,21 @@
               </a:defRPr>
             </a:pPr>
             <a:r>
-              <a:t>108.5°</a:t>
-            </a:r>
-          </a:p>
-        </p:txBody>
-      </p:sp>
-      <p:sp>
-        <p:nvSpPr>
-          <p:cNvPr id="19" name="TextBox 18"/>
+              <a:t>② 近期存在旋转运动</a:t>
+            </a:r>
+          </a:p>
+        </p:txBody>
+      </p:sp>
+      <p:sp>
+        <p:nvSpPr>
+          <p:cNvPr id="20" name="TextBox 19"/>
           <p:cNvSpPr txBox="1"/>
           <p:nvPr/>
         </p:nvSpPr>
         <p:spPr>
           <a:xfrm>
-            <a:off x="850392" y="4832604"/>
-            <a:ext cx="822960" cy="237744"/>
+            <a:off x="6373368" y="4023360"/>
+            <a:ext cx="4937760" cy="256032"/>
           </a:xfrm>
           <a:prstGeom prst="rect">
             <a:avLst/>
@@ -4286,7 +4326,7 @@
               <a:spcAft>
                 <a:spcPts val="700"/>
               </a:spcAft>
-              <a:defRPr sz="1100" b="0">
+              <a:defRPr sz="1200" b="0">
                 <a:solidFill>
                   <a:srgbClr val="62748A"/>
                 </a:solidFill>
@@ -4294,21 +4334,181 @@
               </a:defRPr>
             </a:pPr>
             <a:r>
-              <a:t>对照组</a:t>
-            </a:r>
-          </a:p>
-        </p:txBody>
-      </p:sp>
-      <p:sp>
-        <p:nvSpPr>
-          <p:cNvPr id="20" name="Rounded Rectangle 19"/>
+              <a:t>历史平均步间转角（中位数）</a:t>
+            </a:r>
+          </a:p>
+        </p:txBody>
+      </p:sp>
+      <p:sp>
+        <p:nvSpPr>
+          <p:cNvPr id="21" name="TextBox 20"/>
+          <p:cNvSpPr txBox="1"/>
+          <p:nvPr/>
+        </p:nvSpPr>
+        <p:spPr>
+          <a:xfrm>
+            <a:off x="6373368" y="4517136"/>
+            <a:ext cx="4937760" cy="502920"/>
+          </a:xfrm>
+          <a:prstGeom prst="rect">
+            <a:avLst/>
+          </a:prstGeom>
+          <a:noFill/>
+          <a:effectLst/>
+        </p:spPr>
+        <p:txBody>
+          <a:bodyPr wrap="none" lIns="0" rIns="0" tIns="0" bIns="0">
+            <a:spAutoFit/>
+          </a:bodyPr>
+          <a:lstStyle/>
+          <a:p>
+            <a:pPr>
+              <a:spcAft>
+                <a:spcPts val="700"/>
+              </a:spcAft>
+              <a:defRPr sz="3000" b="1">
+                <a:solidFill>
+                  <a:srgbClr val="148D91"/>
+                </a:solidFill>
+                <a:latin typeface="Noto Sans CJK SC"/>
+              </a:defRPr>
+            </a:pPr>
+            <a:r>
+              <a:t>14.10°</a:t>
+            </a:r>
+          </a:p>
+        </p:txBody>
+      </p:sp>
+      <p:sp>
+        <p:nvSpPr>
+          <p:cNvPr id="22" name="TextBox 21"/>
+          <p:cNvSpPr txBox="1"/>
+          <p:nvPr/>
+        </p:nvSpPr>
+        <p:spPr>
+          <a:xfrm>
+            <a:off x="6373368" y="5157216"/>
+            <a:ext cx="4937760" cy="219456"/>
+          </a:xfrm>
+          <a:prstGeom prst="rect">
+            <a:avLst/>
+          </a:prstGeom>
+          <a:noFill/>
+          <a:effectLst/>
+        </p:spPr>
+        <p:txBody>
+          <a:bodyPr wrap="none" lIns="0" rIns="0" tIns="0" bIns="0">
+            <a:spAutoFit/>
+          </a:bodyPr>
+          <a:lstStyle/>
+          <a:p>
+            <a:pPr>
+              <a:spcAft>
+                <a:spcPts val="700"/>
+              </a:spcAft>
+              <a:defRPr sz="1000" b="0">
+                <a:solidFill>
+                  <a:srgbClr val="62748A"/>
+                </a:solidFill>
+                <a:latin typeface="Noto Sans CJK SC"/>
+              </a:defRPr>
+            </a:pPr>
+            <a:r>
+              <a:t>过去 3 步绝对航向变化的均值，不是角速度。</a:t>
+            </a:r>
+          </a:p>
+        </p:txBody>
+      </p:sp>
+      <p:sp>
+        <p:nvSpPr>
+          <p:cNvPr id="23" name="TextBox 22"/>
+          <p:cNvSpPr txBox="1"/>
+          <p:nvPr/>
+        </p:nvSpPr>
+        <p:spPr>
+          <a:xfrm>
+            <a:off x="685800" y="5696712"/>
+            <a:ext cx="10826496" cy="246888"/>
+          </a:xfrm>
+          <a:prstGeom prst="rect">
+            <a:avLst/>
+          </a:prstGeom>
+          <a:noFill/>
+          <a:effectLst/>
+        </p:spPr>
+        <p:txBody>
+          <a:bodyPr wrap="none" lIns="0" rIns="0" tIns="0" bIns="0">
+            <a:spAutoFit/>
+          </a:bodyPr>
+          <a:lstStyle/>
+          <a:p>
+            <a:pPr>
+              <a:spcAft>
+                <a:spcPts val="700"/>
+              </a:spcAft>
+              <a:defRPr sz="1050" b="1">
+                <a:solidFill>
+                  <a:srgbClr val="142B46"/>
+                </a:solidFill>
+                <a:latin typeface="Noto Sans CJK SC"/>
+              </a:defRPr>
+            </a:pPr>
+            <a:r>
+              <a:t>其中 93.3% 属于严格转弯：未来 8 步终点横向位移 ≥0.30 m，或航向变化绝对值 ≥45°（真实轨迹判定）。</a:t>
+            </a:r>
+          </a:p>
+        </p:txBody>
+      </p:sp>
+      <p:sp>
+        <p:nvSpPr>
+          <p:cNvPr id="24" name="TextBox 23"/>
+          <p:cNvSpPr txBox="1"/>
+          <p:nvPr/>
+        </p:nvSpPr>
+        <p:spPr>
+          <a:xfrm>
+            <a:off x="685800" y="6016752"/>
+            <a:ext cx="10826496" cy="219456"/>
+          </a:xfrm>
+          <a:prstGeom prst="rect">
+            <a:avLst/>
+          </a:prstGeom>
+          <a:noFill/>
+          <a:effectLst/>
+        </p:spPr>
+        <p:txBody>
+          <a:bodyPr wrap="none" lIns="0" rIns="0" tIns="0" bIns="0">
+            <a:spAutoFit/>
+          </a:bodyPr>
+          <a:lstStyle/>
+          <a:p>
+            <a:pPr>
+              <a:spcAft>
+                <a:spcPts val="700"/>
+              </a:spcAft>
+              <a:defRPr sz="1000" b="0">
+                <a:solidFill>
+                  <a:srgbClr val="62748A"/>
+                </a:solidFill>
+                <a:latin typeface="Noto Sans CJK SC"/>
+              </a:defRPr>
+            </a:pPr>
+            <a:r>
+              <a:t>以上为难例内部描述，不能据此判断这些特征比普通样本更强，也不能证明它们导致了预测错误。</a:t>
+            </a:r>
+          </a:p>
+        </p:txBody>
+      </p:sp>
+      <p:sp>
+        <p:nvSpPr>
+          <p:cNvPr id="25" name="Rounded Rectangle 24"/>
           <p:cNvSpPr/>
           <p:nvPr/>
         </p:nvSpPr>
         <p:spPr>
           <a:xfrm>
-            <a:off x="1755648" y="4882896"/>
-            <a:ext cx="1767079" cy="182880"/>
+            <a:off x="685800" y="6373368"/>
+            <a:ext cx="10826496" cy="310896"/>
           </a:xfrm>
           <a:prstGeom prst="roundRect">
             <a:avLst>
@@ -4316,7 +4516,7 @@
             </a:avLst>
           </a:prstGeom>
           <a:solidFill>
-            <a:srgbClr val="9CB5D8"/>
+            <a:srgbClr val="E8F4F2"/>
           </a:solidFill>
           <a:ln>
             <a:noFill/>
@@ -4347,14 +4547,14 @@
       </p:sp>
       <p:sp>
         <p:nvSpPr>
-          <p:cNvPr id="21" name="TextBox 20"/>
+          <p:cNvPr id="26" name="TextBox 25"/>
           <p:cNvSpPr txBox="1"/>
           <p:nvPr/>
         </p:nvSpPr>
         <p:spPr>
           <a:xfrm>
-            <a:off x="4946904" y="4782312"/>
-            <a:ext cx="896112" cy="301752"/>
+            <a:off x="859536" y="6419088"/>
+            <a:ext cx="10424160" cy="219456"/>
           </a:xfrm>
           <a:prstGeom prst="rect">
             <a:avLst/>
@@ -4372,7 +4572,47 @@
               <a:spcAft>
                 <a:spcPts val="700"/>
               </a:spcAft>
-              <a:defRPr sz="1700" b="1">
+              <a:defRPr sz="1200" b="1">
+                <a:solidFill>
+                  <a:srgbClr val="148D91"/>
+                </a:solidFill>
+                <a:latin typeface="Noto Sans CJK SC"/>
+              </a:defRPr>
+            </a:pPr>
+            <a:r>
+              <a:t>下一步假设：难例多发生于转弯过程，检验加入历史图像能否帮助方向预测。</a:t>
+            </a:r>
+          </a:p>
+        </p:txBody>
+      </p:sp>
+      <p:sp>
+        <p:nvSpPr>
+          <p:cNvPr id="27" name="TextBox 26"/>
+          <p:cNvSpPr txBox="1"/>
+          <p:nvPr/>
+        </p:nvSpPr>
+        <p:spPr>
+          <a:xfrm>
+            <a:off x="685800" y="6757416"/>
+            <a:ext cx="10058400" cy="118872"/>
+          </a:xfrm>
+          <a:prstGeom prst="rect">
+            <a:avLst/>
+          </a:prstGeom>
+          <a:noFill/>
+          <a:effectLst/>
+        </p:spPr>
+        <p:txBody>
+          <a:bodyPr wrap="none" lIns="0" rIns="0" tIns="0" bIns="0">
+            <a:spAutoFit/>
+          </a:bodyPr>
+          <a:lstStyle/>
+          <a:p>
+            <a:pPr>
+              <a:spcAft>
+                <a:spcPts val="700"/>
+              </a:spcAft>
+              <a:defRPr sz="750" b="0">
                 <a:solidFill>
                   <a:srgbClr val="62748A"/>
                 </a:solidFill>
@@ -4380,21 +4620,21 @@
               </a:defRPr>
             </a:pPr>
             <a:r>
-              <a:t>69.4°</a:t>
-            </a:r>
-          </a:p>
-        </p:txBody>
-      </p:sp>
-      <p:sp>
-        <p:nvSpPr>
-          <p:cNvPr id="22" name="TextBox 21"/>
+              <a:t>来源：wp_hard120/summary.txt、enrichment_H_vs_control.csv；只使用困难组统计，未重跑实验。</a:t>
+            </a:r>
+          </a:p>
+        </p:txBody>
+      </p:sp>
+      <p:sp>
+        <p:nvSpPr>
+          <p:cNvPr id="28" name="TextBox 27"/>
           <p:cNvSpPr txBox="1"/>
           <p:nvPr/>
         </p:nvSpPr>
         <p:spPr>
           <a:xfrm>
-            <a:off x="850392" y="5285232"/>
-            <a:ext cx="4937760" cy="219456"/>
+            <a:off x="10378440" y="6757416"/>
+            <a:ext cx="1133856" cy="118872"/>
           </a:xfrm>
           <a:prstGeom prst="rect">
             <a:avLst/>
@@ -4412,631 +4652,7 @@
               <a:spcAft>
                 <a:spcPts val="700"/>
               </a:spcAft>
-              <a:defRPr sz="1000" b="0">
-                <a:solidFill>
-                  <a:srgbClr val="62748A"/>
-                </a:solidFill>
-                <a:latin typeface="Noto Sans CJK SC"/>
-              </a:defRPr>
-            </a:pPr>
-            <a:r>
-              <a:t>每步转了多少角度，取绝对值后累加。</a:t>
-            </a:r>
-          </a:p>
-        </p:txBody>
-      </p:sp>
-      <p:sp>
-        <p:nvSpPr>
-          <p:cNvPr id="23" name="Rounded Rectangle 22"/>
-          <p:cNvSpPr/>
-          <p:nvPr/>
-        </p:nvSpPr>
-        <p:spPr>
-          <a:xfrm>
-            <a:off x="6208776" y="3310128"/>
-            <a:ext cx="5303520" cy="2276856"/>
-          </a:xfrm>
-          <a:prstGeom prst="roundRect">
-            <a:avLst>
-              <a:gd name="adj" fmla="val 12000"/>
-            </a:avLst>
-          </a:prstGeom>
-          <a:solidFill>
-            <a:srgbClr val="F0F4F8"/>
-          </a:solidFill>
-          <a:ln>
-            <a:noFill/>
-          </a:ln>
-          <a:effectLst/>
-        </p:spPr>
-        <p:style>
-          <a:lnRef idx="1">
-            <a:schemeClr val="accent1"/>
-          </a:lnRef>
-          <a:fillRef idx="3">
-            <a:schemeClr val="accent1"/>
-          </a:fillRef>
-          <a:effectRef idx="0">
-            <a:schemeClr val="accent1"/>
-          </a:effectRef>
-          <a:fontRef idx="minor">
-            <a:schemeClr val="lt1"/>
-          </a:fontRef>
-        </p:style>
-        <p:txBody>
-          <a:bodyPr rtlCol="0" anchor="ctr"/>
-          <a:lstStyle/>
-          <a:p>
-            <a:pPr algn="ctr"/>
-          </a:p>
-        </p:txBody>
-      </p:sp>
-      <p:sp>
-        <p:nvSpPr>
-          <p:cNvPr id="24" name="TextBox 23"/>
-          <p:cNvSpPr txBox="1"/>
-          <p:nvPr/>
-        </p:nvSpPr>
-        <p:spPr>
-          <a:xfrm>
-            <a:off x="6373368" y="3456432"/>
-            <a:ext cx="4937760" cy="329184"/>
-          </a:xfrm>
-          <a:prstGeom prst="rect">
-            <a:avLst/>
-          </a:prstGeom>
-          <a:noFill/>
-          <a:effectLst/>
-        </p:spPr>
-        <p:txBody>
-          <a:bodyPr wrap="none" lIns="0" rIns="0" tIns="0" bIns="0">
-            <a:spAutoFit/>
-          </a:bodyPr>
-          <a:lstStyle/>
-          <a:p>
-            <a:pPr>
-              <a:spcAft>
-                <a:spcPts val="700"/>
-              </a:spcAft>
-              <a:defRPr sz="2000" b="1">
-                <a:solidFill>
-                  <a:srgbClr val="148D91"/>
-                </a:solidFill>
-                <a:latin typeface="Noto Sans CJK SC"/>
-              </a:defRPr>
-            </a:pPr>
-            <a:r>
-              <a:t>② 近期旋转更强</a:t>
-            </a:r>
-          </a:p>
-        </p:txBody>
-      </p:sp>
-      <p:sp>
-        <p:nvSpPr>
-          <p:cNvPr id="25" name="TextBox 24"/>
-          <p:cNvSpPr txBox="1"/>
-          <p:nvPr/>
-        </p:nvSpPr>
-        <p:spPr>
-          <a:xfrm>
-            <a:off x="6373368" y="3922776"/>
-            <a:ext cx="4937760" cy="246888"/>
-          </a:xfrm>
-          <a:prstGeom prst="rect">
-            <a:avLst/>
-          </a:prstGeom>
-          <a:noFill/>
-          <a:effectLst/>
-        </p:spPr>
-        <p:txBody>
-          <a:bodyPr wrap="none" lIns="0" rIns="0" tIns="0" bIns="0">
-            <a:spAutoFit/>
-          </a:bodyPr>
-          <a:lstStyle/>
-          <a:p>
-            <a:pPr>
-              <a:spcAft>
-                <a:spcPts val="700"/>
-              </a:spcAft>
-              <a:defRPr sz="1200" b="0">
-                <a:solidFill>
-                  <a:srgbClr val="62748A"/>
-                </a:solidFill>
-                <a:latin typeface="Noto Sans CJK SC"/>
-              </a:defRPr>
-            </a:pPr>
-            <a:r>
-              <a:t>历史平均步间转角（中位数）</a:t>
-            </a:r>
-          </a:p>
-        </p:txBody>
-      </p:sp>
-      <p:sp>
-        <p:nvSpPr>
-          <p:cNvPr id="26" name="TextBox 25"/>
-          <p:cNvSpPr txBox="1"/>
-          <p:nvPr/>
-        </p:nvSpPr>
-        <p:spPr>
-          <a:xfrm>
-            <a:off x="6373368" y="4393692"/>
-            <a:ext cx="822960" cy="237744"/>
-          </a:xfrm>
-          <a:prstGeom prst="rect">
-            <a:avLst/>
-          </a:prstGeom>
-          <a:noFill/>
-          <a:effectLst/>
-        </p:spPr>
-        <p:txBody>
-          <a:bodyPr wrap="none" lIns="0" rIns="0" tIns="0" bIns="0">
-            <a:spAutoFit/>
-          </a:bodyPr>
-          <a:lstStyle/>
-          <a:p>
-            <a:pPr>
-              <a:spcAft>
-                <a:spcPts val="700"/>
-              </a:spcAft>
-              <a:defRPr sz="1100" b="0">
-                <a:solidFill>
-                  <a:srgbClr val="62748A"/>
-                </a:solidFill>
-                <a:latin typeface="Noto Sans CJK SC"/>
-              </a:defRPr>
-            </a:pPr>
-            <a:r>
-              <a:t>困难组</a:t>
-            </a:r>
-          </a:p>
-        </p:txBody>
-      </p:sp>
-      <p:sp>
-        <p:nvSpPr>
-          <p:cNvPr id="27" name="Rounded Rectangle 26"/>
-          <p:cNvSpPr/>
-          <p:nvPr/>
-        </p:nvSpPr>
-        <p:spPr>
-          <a:xfrm>
-            <a:off x="7278624" y="4443984"/>
-            <a:ext cx="2691634" cy="182880"/>
-          </a:xfrm>
-          <a:prstGeom prst="roundRect">
-            <a:avLst>
-              <a:gd name="adj" fmla="val 12000"/>
-            </a:avLst>
-          </a:prstGeom>
-          <a:solidFill>
-            <a:srgbClr val="148D91"/>
-          </a:solidFill>
-          <a:ln>
-            <a:noFill/>
-          </a:ln>
-          <a:effectLst/>
-        </p:spPr>
-        <p:style>
-          <a:lnRef idx="1">
-            <a:schemeClr val="accent1"/>
-          </a:lnRef>
-          <a:fillRef idx="3">
-            <a:schemeClr val="accent1"/>
-          </a:fillRef>
-          <a:effectRef idx="0">
-            <a:schemeClr val="accent1"/>
-          </a:effectRef>
-          <a:fontRef idx="minor">
-            <a:schemeClr val="lt1"/>
-          </a:fontRef>
-        </p:style>
-        <p:txBody>
-          <a:bodyPr rtlCol="0" anchor="ctr"/>
-          <a:lstStyle/>
-          <a:p>
-            <a:pPr algn="ctr"/>
-          </a:p>
-        </p:txBody>
-      </p:sp>
-      <p:sp>
-        <p:nvSpPr>
-          <p:cNvPr id="28" name="TextBox 27"/>
-          <p:cNvSpPr txBox="1"/>
-          <p:nvPr/>
-        </p:nvSpPr>
-        <p:spPr>
-          <a:xfrm>
-            <a:off x="10469880" y="4343400"/>
-            <a:ext cx="896112" cy="301752"/>
-          </a:xfrm>
-          <a:prstGeom prst="rect">
-            <a:avLst/>
-          </a:prstGeom>
-          <a:noFill/>
-          <a:effectLst/>
-        </p:spPr>
-        <p:txBody>
-          <a:bodyPr wrap="none" lIns="0" rIns="0" tIns="0" bIns="0">
-            <a:spAutoFit/>
-          </a:bodyPr>
-          <a:lstStyle/>
-          <a:p>
-            <a:pPr>
-              <a:spcAft>
-                <a:spcPts val="700"/>
-              </a:spcAft>
-              <a:defRPr sz="1700" b="1">
-                <a:solidFill>
-                  <a:srgbClr val="148D91"/>
-                </a:solidFill>
-                <a:latin typeface="Noto Sans CJK SC"/>
-              </a:defRPr>
-            </a:pPr>
-            <a:r>
-              <a:t>14.10°</a:t>
-            </a:r>
-          </a:p>
-        </p:txBody>
-      </p:sp>
-      <p:sp>
-        <p:nvSpPr>
-          <p:cNvPr id="29" name="TextBox 28"/>
-          <p:cNvSpPr txBox="1"/>
-          <p:nvPr/>
-        </p:nvSpPr>
-        <p:spPr>
-          <a:xfrm>
-            <a:off x="6373368" y="4832604"/>
-            <a:ext cx="822960" cy="237744"/>
-          </a:xfrm>
-          <a:prstGeom prst="rect">
-            <a:avLst/>
-          </a:prstGeom>
-          <a:noFill/>
-          <a:effectLst/>
-        </p:spPr>
-        <p:txBody>
-          <a:bodyPr wrap="none" lIns="0" rIns="0" tIns="0" bIns="0">
-            <a:spAutoFit/>
-          </a:bodyPr>
-          <a:lstStyle/>
-          <a:p>
-            <a:pPr>
-              <a:spcAft>
-                <a:spcPts val="700"/>
-              </a:spcAft>
-              <a:defRPr sz="1100" b="0">
-                <a:solidFill>
-                  <a:srgbClr val="62748A"/>
-                </a:solidFill>
-                <a:latin typeface="Noto Sans CJK SC"/>
-              </a:defRPr>
-            </a:pPr>
-            <a:r>
-              <a:t>对照组</a:t>
-            </a:r>
-          </a:p>
-        </p:txBody>
-      </p:sp>
-      <p:sp>
-        <p:nvSpPr>
-          <p:cNvPr id="30" name="Rounded Rectangle 29"/>
-          <p:cNvSpPr/>
-          <p:nvPr/>
-        </p:nvSpPr>
-        <p:spPr>
-          <a:xfrm>
-            <a:off x="7278624" y="4882896"/>
-            <a:ext cx="1402869" cy="182880"/>
-          </a:xfrm>
-          <a:prstGeom prst="roundRect">
-            <a:avLst>
-              <a:gd name="adj" fmla="val 12000"/>
-            </a:avLst>
-          </a:prstGeom>
-          <a:solidFill>
-            <a:srgbClr val="9CB5D8"/>
-          </a:solidFill>
-          <a:ln>
-            <a:noFill/>
-          </a:ln>
-          <a:effectLst/>
-        </p:spPr>
-        <p:style>
-          <a:lnRef idx="1">
-            <a:schemeClr val="accent1"/>
-          </a:lnRef>
-          <a:fillRef idx="3">
-            <a:schemeClr val="accent1"/>
-          </a:fillRef>
-          <a:effectRef idx="0">
-            <a:schemeClr val="accent1"/>
-          </a:effectRef>
-          <a:fontRef idx="minor">
-            <a:schemeClr val="lt1"/>
-          </a:fontRef>
-        </p:style>
-        <p:txBody>
-          <a:bodyPr rtlCol="0" anchor="ctr"/>
-          <a:lstStyle/>
-          <a:p>
-            <a:pPr algn="ctr"/>
-          </a:p>
-        </p:txBody>
-      </p:sp>
-      <p:sp>
-        <p:nvSpPr>
-          <p:cNvPr id="31" name="TextBox 30"/>
-          <p:cNvSpPr txBox="1"/>
-          <p:nvPr/>
-        </p:nvSpPr>
-        <p:spPr>
-          <a:xfrm>
-            <a:off x="10469880" y="4782312"/>
-            <a:ext cx="896112" cy="301752"/>
-          </a:xfrm>
-          <a:prstGeom prst="rect">
-            <a:avLst/>
-          </a:prstGeom>
-          <a:noFill/>
-          <a:effectLst/>
-        </p:spPr>
-        <p:txBody>
-          <a:bodyPr wrap="none" lIns="0" rIns="0" tIns="0" bIns="0">
-            <a:spAutoFit/>
-          </a:bodyPr>
-          <a:lstStyle/>
-          <a:p>
-            <a:pPr>
-              <a:spcAft>
-                <a:spcPts val="700"/>
-              </a:spcAft>
-              <a:defRPr sz="1700" b="1">
-                <a:solidFill>
-                  <a:srgbClr val="62748A"/>
-                </a:solidFill>
-                <a:latin typeface="Noto Sans CJK SC"/>
-              </a:defRPr>
-            </a:pPr>
-            <a:r>
-              <a:t>7.35°</a:t>
-            </a:r>
-          </a:p>
-        </p:txBody>
-      </p:sp>
-      <p:sp>
-        <p:nvSpPr>
-          <p:cNvPr id="32" name="TextBox 31"/>
-          <p:cNvSpPr txBox="1"/>
-          <p:nvPr/>
-        </p:nvSpPr>
-        <p:spPr>
-          <a:xfrm>
-            <a:off x="6373368" y="5285232"/>
-            <a:ext cx="4937760" cy="219456"/>
-          </a:xfrm>
-          <a:prstGeom prst="rect">
-            <a:avLst/>
-          </a:prstGeom>
-          <a:noFill/>
-          <a:effectLst/>
-        </p:spPr>
-        <p:txBody>
-          <a:bodyPr wrap="none" lIns="0" rIns="0" tIns="0" bIns="0">
-            <a:spAutoFit/>
-          </a:bodyPr>
-          <a:lstStyle/>
-          <a:p>
-            <a:pPr>
-              <a:spcAft>
-                <a:spcPts val="700"/>
-              </a:spcAft>
-              <a:defRPr sz="1000" b="0">
-                <a:solidFill>
-                  <a:srgbClr val="62748A"/>
-                </a:solidFill>
-                <a:latin typeface="Noto Sans CJK SC"/>
-              </a:defRPr>
-            </a:pPr>
-            <a:r>
-              <a:t>过去 3 步绝对航向变化的均值。</a:t>
-            </a:r>
-          </a:p>
-        </p:txBody>
-      </p:sp>
-      <p:sp>
-        <p:nvSpPr>
-          <p:cNvPr id="33" name="TextBox 32"/>
-          <p:cNvSpPr txBox="1"/>
-          <p:nvPr/>
-        </p:nvSpPr>
-        <p:spPr>
-          <a:xfrm>
-            <a:off x="685800" y="5806440"/>
-            <a:ext cx="10826496" cy="265176"/>
-          </a:xfrm>
-          <a:prstGeom prst="rect">
-            <a:avLst/>
-          </a:prstGeom>
-          <a:noFill/>
-          <a:effectLst/>
-        </p:spPr>
-        <p:txBody>
-          <a:bodyPr wrap="none" lIns="0" rIns="0" tIns="0" bIns="0">
-            <a:spAutoFit/>
-          </a:bodyPr>
-          <a:lstStyle/>
-          <a:p>
-            <a:pPr>
-              <a:spcAft>
-                <a:spcPts val="700"/>
-              </a:spcAft>
-              <a:defRPr sz="1000" b="0">
-                <a:solidFill>
-                  <a:srgbClr val="62748A"/>
-                </a:solidFill>
-                <a:latin typeface="Noto Sans CJK SC"/>
-              </a:defRPr>
-            </a:pPr>
-            <a:r>
-              <a:t>这些是组间相关特征；对照只匹配了转弯比例，尚不能证明近期旋转或路径弯曲导致预测错误。</a:t>
-            </a:r>
-          </a:p>
-        </p:txBody>
-      </p:sp>
-      <p:sp>
-        <p:nvSpPr>
-          <p:cNvPr id="34" name="Rounded Rectangle 33"/>
-          <p:cNvSpPr/>
-          <p:nvPr/>
-        </p:nvSpPr>
-        <p:spPr>
-          <a:xfrm>
-            <a:off x="685800" y="6199632"/>
-            <a:ext cx="10826496" cy="411480"/>
-          </a:xfrm>
-          <a:prstGeom prst="roundRect">
-            <a:avLst>
-              <a:gd name="adj" fmla="val 12000"/>
-            </a:avLst>
-          </a:prstGeom>
-          <a:solidFill>
-            <a:srgbClr val="E8F4F2"/>
-          </a:solidFill>
-          <a:ln>
-            <a:noFill/>
-          </a:ln>
-          <a:effectLst/>
-        </p:spPr>
-        <p:style>
-          <a:lnRef idx="1">
-            <a:schemeClr val="accent1"/>
-          </a:lnRef>
-          <a:fillRef idx="3">
-            <a:schemeClr val="accent1"/>
-          </a:fillRef>
-          <a:effectRef idx="0">
-            <a:schemeClr val="accent1"/>
-          </a:effectRef>
-          <a:fontRef idx="minor">
-            <a:schemeClr val="lt1"/>
-          </a:fontRef>
-        </p:style>
-        <p:txBody>
-          <a:bodyPr rtlCol="0" anchor="ctr"/>
-          <a:lstStyle/>
-          <a:p>
-            <a:pPr algn="ctr"/>
-          </a:p>
-        </p:txBody>
-      </p:sp>
-      <p:sp>
-        <p:nvSpPr>
-          <p:cNvPr id="35" name="TextBox 34"/>
-          <p:cNvSpPr txBox="1"/>
-          <p:nvPr/>
-        </p:nvSpPr>
-        <p:spPr>
-          <a:xfrm>
-            <a:off x="859536" y="6272784"/>
-            <a:ext cx="10424160" cy="265176"/>
-          </a:xfrm>
-          <a:prstGeom prst="rect">
-            <a:avLst/>
-          </a:prstGeom>
-          <a:noFill/>
-          <a:effectLst/>
-        </p:spPr>
-        <p:txBody>
-          <a:bodyPr wrap="none" lIns="0" rIns="0" tIns="0" bIns="0">
-            <a:spAutoFit/>
-          </a:bodyPr>
-          <a:lstStyle/>
-          <a:p>
-            <a:pPr>
-              <a:spcAft>
-                <a:spcPts val="700"/>
-              </a:spcAft>
-              <a:defRPr sz="1300" b="1">
-                <a:solidFill>
-                  <a:srgbClr val="148D91"/>
-                </a:solidFill>
-                <a:latin typeface="Noto Sans CJK SC"/>
-              </a:defRPr>
-            </a:pPr>
-            <a:r>
-              <a:t>下一步假设：既然难例伴随更强的近期旋转，就检验视觉历史能否帮助方向预测。</a:t>
-            </a:r>
-          </a:p>
-        </p:txBody>
-      </p:sp>
-      <p:sp>
-        <p:nvSpPr>
-          <p:cNvPr id="36" name="TextBox 35"/>
-          <p:cNvSpPr txBox="1"/>
-          <p:nvPr/>
-        </p:nvSpPr>
-        <p:spPr>
-          <a:xfrm>
-            <a:off x="685800" y="6684264"/>
-            <a:ext cx="10058400" cy="146304"/>
-          </a:xfrm>
-          <a:prstGeom prst="rect">
-            <a:avLst/>
-          </a:prstGeom>
-          <a:noFill/>
-          <a:effectLst/>
-        </p:spPr>
-        <p:txBody>
-          <a:bodyPr wrap="none" lIns="0" rIns="0" tIns="0" bIns="0">
-            <a:spAutoFit/>
-          </a:bodyPr>
-          <a:lstStyle/>
-          <a:p>
-            <a:pPr>
-              <a:spcAft>
-                <a:spcPts val="700"/>
-              </a:spcAft>
-              <a:defRPr sz="800" b="0">
-                <a:solidFill>
-                  <a:srgbClr val="62748A"/>
-                </a:solidFill>
-                <a:latin typeface="Noto Sans CJK SC"/>
-              </a:defRPr>
-            </a:pPr>
-            <a:r>
-              <a:t>来源：wp_hard120/summary.txt、enrichment_H_vs_control.csv（C_match）；两图按各自指标独立定标。</a:t>
-            </a:r>
-          </a:p>
-        </p:txBody>
-      </p:sp>
-      <p:sp>
-        <p:nvSpPr>
-          <p:cNvPr id="37" name="TextBox 36"/>
-          <p:cNvSpPr txBox="1"/>
-          <p:nvPr/>
-        </p:nvSpPr>
-        <p:spPr>
-          <a:xfrm>
-            <a:off x="10378440" y="6684264"/>
-            <a:ext cx="1133856" cy="146304"/>
-          </a:xfrm>
-          <a:prstGeom prst="rect">
-            <a:avLst/>
-          </a:prstGeom>
-          <a:noFill/>
-          <a:effectLst/>
-        </p:spPr>
-        <p:txBody>
-          <a:bodyPr wrap="none" lIns="0" rIns="0" tIns="0" bIns="0">
-            <a:spAutoFit/>
-          </a:bodyPr>
-          <a:lstStyle/>
-          <a:p>
-            <a:pPr>
-              <a:spcAft>
-                <a:spcPts val="700"/>
-              </a:spcAft>
-              <a:defRPr sz="800" b="0">
+              <a:defRPr sz="750" b="0">
                 <a:solidFill>
                   <a:srgbClr val="62748A"/>
                 </a:solidFill>

</xml_diff>